<commit_message>
Update 눈높이 퀴즈 assets and add ZIP slides
Co-Authored-By: Claude Opus 4.6 (1M context) <noreply@anthropic.com>
</commit_message>
<xml_diff>
--- a/public/downloads/games/eye-level-quiz/rules.pptx
+++ b/public/downloads/games/eye-level-quiz/rules.pptx
@@ -54,20 +54,17 @@
     <p:sldId id="302" r:id="rId52"/>
     <p:sldId id="303" r:id="rId53"/>
     <p:sldId id="304" r:id="rId54"/>
+    <p:sldId id="305" r:id="rId55"/>
   </p:sldIdLst>
   <p:sldSz cx="18288000" cy="10287000"/>
   <p:notesSz cx="6858000" cy="9144000"/>
   <p:embeddedFontLst>
     <p:embeddedFont>
-      <p:font typeface="Jua" charset="1" panose="00000000000000000000"/>
-      <p:regular r:id="rId55"/>
-    </p:embeddedFont>
-    <p:embeddedFont>
-      <p:font typeface="TDTD갬성명조" charset="1" panose="02000503000000000000"/>
+      <p:font typeface="무궁화 고딕" charset="1" panose="02020603020101020101"/>
       <p:regular r:id="rId56"/>
     </p:embeddedFont>
     <p:embeddedFont>
-      <p:font typeface="TDTD가온" charset="1" panose="02000503000000000000"/>
+      <p:font typeface="무궁화 고딕 Bold" charset="1" panose="02020603020101020101"/>
       <p:regular r:id="rId57"/>
     </p:embeddedFont>
   </p:embeddedFontLst>
@@ -3186,8 +3183,8 @@
         </p:nvSpPr>
         <p:spPr>
           <a:xfrm rot="0">
-            <a:off x="1028700" y="3892867"/>
-            <a:ext cx="15555091" cy="2200275"/>
+            <a:off x="1028700" y="4178617"/>
+            <a:ext cx="15555091" cy="1914525"/>
           </a:xfrm>
           <a:prstGeom prst="rect">
             <a:avLst/>
@@ -3209,10 +3206,10 @@
                 <a:solidFill>
                   <a:srgbClr val="FFFAEF"/>
                 </a:solidFill>
-                <a:latin typeface="Jua"/>
-                <a:ea typeface="Jua"/>
-                <a:cs typeface="Jua"/>
-                <a:sym typeface="Jua"/>
+                <a:latin typeface="무궁화 고딕"/>
+                <a:ea typeface="무궁화 고딕"/>
+                <a:cs typeface="무궁화 고딕"/>
+                <a:sym typeface="무궁화 고딕"/>
               </a:rPr>
               <a:t>눈높이 퀴즈</a:t>
             </a:r>
@@ -3227,8 +3224,8 @@
         </p:nvSpPr>
         <p:spPr>
           <a:xfrm rot="0">
-            <a:off x="15264803" y="9812655"/>
-            <a:ext cx="2637975" cy="474345"/>
+            <a:off x="14522856" y="9822180"/>
+            <a:ext cx="3379923" cy="464820"/>
           </a:xfrm>
           <a:prstGeom prst="rect">
             <a:avLst/>
@@ -3253,10 +3250,10 @@
                 <a:solidFill>
                   <a:srgbClr val="FFFFFF"/>
                 </a:solidFill>
-                <a:latin typeface="TDTD갬성명조"/>
-                <a:ea typeface="TDTD갬성명조"/>
-                <a:cs typeface="TDTD갬성명조"/>
-                <a:sym typeface="TDTD갬성명조"/>
+                <a:latin typeface="무궁화 고딕"/>
+                <a:ea typeface="무궁화 고딕"/>
+                <a:cs typeface="무궁화 고딕"/>
+                <a:sym typeface="무궁화 고딕"/>
               </a:rPr>
               <a:t>ⓒ 2026. Sunday Play</a:t>
             </a:r>
@@ -3353,8 +3350,8 @@
         </p:nvSpPr>
         <p:spPr>
           <a:xfrm rot="0">
-            <a:off x="2717556" y="3390900"/>
-            <a:ext cx="13815414" cy="3267075"/>
+            <a:off x="2717556" y="4181475"/>
+            <a:ext cx="12852888" cy="1914525"/>
           </a:xfrm>
           <a:prstGeom prst="rect">
             <a:avLst/>
@@ -3368,20 +3365,20 @@
           <a:p>
             <a:pPr algn="ctr">
               <a:lnSpc>
-                <a:spcPts val="11999"/>
+                <a:spcPts val="15000"/>
               </a:lnSpc>
             </a:pPr>
             <a:r>
-              <a:rPr lang="en-US" sz="9999">
+              <a:rPr lang="en-US" sz="12500">
                 <a:solidFill>
                   <a:srgbClr val="000000"/>
                 </a:solidFill>
-                <a:latin typeface="Jua"/>
-                <a:ea typeface="Jua"/>
-                <a:cs typeface="Jua"/>
-                <a:sym typeface="Jua"/>
+                <a:latin typeface="무궁화 고딕"/>
+                <a:ea typeface="무궁화 고딕"/>
+                <a:cs typeface="무궁화 고딕"/>
+                <a:sym typeface="무궁화 고딕"/>
               </a:rPr>
-              <a:t>차가운 방인데 불 끄면 깜깜해지고 문 닫으면 다시 켜져요</a:t>
+              <a:t>면도</a:t>
             </a:r>
           </a:p>
         </p:txBody>
@@ -3476,8 +3473,8 @@
         </p:nvSpPr>
         <p:spPr>
           <a:xfrm rot="0">
-            <a:off x="2717556" y="7505700"/>
-            <a:ext cx="12852888" cy="1752600"/>
+            <a:off x="2717556" y="3905250"/>
+            <a:ext cx="13815414" cy="2466975"/>
           </a:xfrm>
           <a:prstGeom prst="rect">
             <a:avLst/>
@@ -3491,59 +3488,18 @@
           <a:p>
             <a:pPr algn="ctr">
               <a:lnSpc>
-                <a:spcPts val="11999"/>
+                <a:spcPts val="9720"/>
               </a:lnSpc>
             </a:pPr>
             <a:r>
-              <a:rPr lang="en-US" sz="9999">
-                <a:solidFill>
-                  <a:srgbClr val="7D8AAB"/>
-                </a:solidFill>
-                <a:latin typeface="Jua"/>
-                <a:ea typeface="Jua"/>
-                <a:cs typeface="Jua"/>
-                <a:sym typeface="Jua"/>
-              </a:rPr>
-              <a:t>Hint. 먹을 것이 많아요</a:t>
-            </a:r>
-          </a:p>
-        </p:txBody>
-      </p:sp>
-      <p:sp>
-        <p:nvSpPr>
-          <p:cNvPr name="TextBox 5" id="5"/>
-          <p:cNvSpPr txBox="true"/>
-          <p:nvPr/>
-        </p:nvSpPr>
-        <p:spPr>
-          <a:xfrm rot="0">
-            <a:off x="2717556" y="3390900"/>
-            <a:ext cx="13815414" cy="3267075"/>
-          </a:xfrm>
-          <a:prstGeom prst="rect">
-            <a:avLst/>
-          </a:prstGeom>
-        </p:spPr>
-        <p:txBody>
-          <a:bodyPr anchor="t" rtlCol="false" tIns="0" lIns="0" bIns="0" rIns="0">
-            <a:spAutoFit/>
-          </a:bodyPr>
-          <a:lstStyle/>
-          <a:p>
-            <a:pPr algn="ctr">
-              <a:lnSpc>
-                <a:spcPts val="11999"/>
-              </a:lnSpc>
-            </a:pPr>
-            <a:r>
-              <a:rPr lang="en-US" sz="9999">
+              <a:rPr lang="en-US" sz="8100">
                 <a:solidFill>
                   <a:srgbClr val="000000"/>
                 </a:solidFill>
-                <a:latin typeface="Jua"/>
-                <a:ea typeface="Jua"/>
-                <a:cs typeface="Jua"/>
-                <a:sym typeface="Jua"/>
+                <a:latin typeface="무궁화 고딕"/>
+                <a:ea typeface="무궁화 고딕"/>
+                <a:cs typeface="무궁화 고딕"/>
+                <a:sym typeface="무궁화 고딕"/>
               </a:rPr>
               <a:t>차가운 방인데 불 끄면 깜깜해지고 문 닫으면 다시 켜져요</a:t>
             </a:r>
@@ -3640,8 +3596,8 @@
         </p:nvSpPr>
         <p:spPr>
           <a:xfrm rot="0">
-            <a:off x="2717556" y="3895725"/>
-            <a:ext cx="12852888" cy="2200275"/>
+            <a:off x="2717556" y="7815263"/>
+            <a:ext cx="12852888" cy="1362075"/>
           </a:xfrm>
           <a:prstGeom prst="rect">
             <a:avLst/>
@@ -3655,20 +3611,61 @@
           <a:p>
             <a:pPr algn="ctr">
               <a:lnSpc>
-                <a:spcPts val="15000"/>
+                <a:spcPts val="10680"/>
               </a:lnSpc>
             </a:pPr>
             <a:r>
-              <a:rPr lang="en-US" sz="12500">
+              <a:rPr lang="en-US" sz="8900">
+                <a:solidFill>
+                  <a:srgbClr val="7D8AAB"/>
+                </a:solidFill>
+                <a:latin typeface="무궁화 고딕"/>
+                <a:ea typeface="무궁화 고딕"/>
+                <a:cs typeface="무궁화 고딕"/>
+                <a:sym typeface="무궁화 고딕"/>
+              </a:rPr>
+              <a:t>Hint. 먹을 것이 많아요</a:t>
+            </a:r>
+          </a:p>
+        </p:txBody>
+      </p:sp>
+      <p:sp>
+        <p:nvSpPr>
+          <p:cNvPr name="TextBox 5" id="5"/>
+          <p:cNvSpPr txBox="true"/>
+          <p:nvPr/>
+        </p:nvSpPr>
+        <p:spPr>
+          <a:xfrm rot="0">
+            <a:off x="2717556" y="3905250"/>
+            <a:ext cx="13815414" cy="2466975"/>
+          </a:xfrm>
+          <a:prstGeom prst="rect">
+            <a:avLst/>
+          </a:prstGeom>
+        </p:spPr>
+        <p:txBody>
+          <a:bodyPr anchor="t" rtlCol="false" tIns="0" lIns="0" bIns="0" rIns="0">
+            <a:spAutoFit/>
+          </a:bodyPr>
+          <a:lstStyle/>
+          <a:p>
+            <a:pPr algn="ctr">
+              <a:lnSpc>
+                <a:spcPts val="9720"/>
+              </a:lnSpc>
+            </a:pPr>
+            <a:r>
+              <a:rPr lang="en-US" sz="8100">
                 <a:solidFill>
                   <a:srgbClr val="000000"/>
                 </a:solidFill>
-                <a:latin typeface="Jua"/>
-                <a:ea typeface="Jua"/>
-                <a:cs typeface="Jua"/>
-                <a:sym typeface="Jua"/>
+                <a:latin typeface="무궁화 고딕"/>
+                <a:ea typeface="무궁화 고딕"/>
+                <a:cs typeface="무궁화 고딕"/>
+                <a:sym typeface="무궁화 고딕"/>
               </a:rPr>
-              <a:t>냉장고</a:t>
+              <a:t>차가운 방인데 불 끄면 깜깜해지고 문 닫으면 다시 켜져요</a:t>
             </a:r>
           </a:p>
         </p:txBody>
@@ -3763,8 +3760,8 @@
         </p:nvSpPr>
         <p:spPr>
           <a:xfrm rot="0">
-            <a:off x="2717556" y="2943225"/>
-            <a:ext cx="12852888" cy="4105275"/>
+            <a:off x="2717556" y="4181475"/>
+            <a:ext cx="12852888" cy="1914525"/>
           </a:xfrm>
           <a:prstGeom prst="rect">
             <a:avLst/>
@@ -3786,12 +3783,12 @@
                 <a:solidFill>
                   <a:srgbClr val="000000"/>
                 </a:solidFill>
-                <a:latin typeface="Jua"/>
-                <a:ea typeface="Jua"/>
-                <a:cs typeface="Jua"/>
-                <a:sym typeface="Jua"/>
+                <a:latin typeface="무궁화 고딕"/>
+                <a:ea typeface="무궁화 고딕"/>
+                <a:cs typeface="무궁화 고딕"/>
+                <a:sym typeface="무궁화 고딕"/>
               </a:rPr>
-              <a:t>엄마가 이걸 만지면 항상 울어요</a:t>
+              <a:t>냉장고</a:t>
             </a:r>
           </a:p>
         </p:txBody>
@@ -3886,49 +3883,8 @@
         </p:nvSpPr>
         <p:spPr>
           <a:xfrm rot="0">
-            <a:off x="2717556" y="7505700"/>
-            <a:ext cx="12852888" cy="1752600"/>
-          </a:xfrm>
-          <a:prstGeom prst="rect">
-            <a:avLst/>
-          </a:prstGeom>
-        </p:spPr>
-        <p:txBody>
-          <a:bodyPr anchor="t" rtlCol="false" tIns="0" lIns="0" bIns="0" rIns="0">
-            <a:spAutoFit/>
-          </a:bodyPr>
-          <a:lstStyle/>
-          <a:p>
-            <a:pPr algn="ctr">
-              <a:lnSpc>
-                <a:spcPts val="11999"/>
-              </a:lnSpc>
-            </a:pPr>
-            <a:r>
-              <a:rPr lang="en-US" sz="9999">
-                <a:solidFill>
-                  <a:srgbClr val="7D8AAB"/>
-                </a:solidFill>
-                <a:latin typeface="Jua"/>
-                <a:ea typeface="Jua"/>
-                <a:cs typeface="Jua"/>
-                <a:sym typeface="Jua"/>
-              </a:rPr>
-              <a:t>Hint.  까면 까수록 나와요</a:t>
-            </a:r>
-          </a:p>
-        </p:txBody>
-      </p:sp>
-      <p:sp>
-        <p:nvSpPr>
-          <p:cNvPr name="TextBox 5" id="5"/>
-          <p:cNvSpPr txBox="true"/>
-          <p:nvPr/>
-        </p:nvSpPr>
-        <p:spPr>
-          <a:xfrm rot="0">
-            <a:off x="2717556" y="2943225"/>
-            <a:ext cx="12852888" cy="4105275"/>
+            <a:off x="2717556" y="3228975"/>
+            <a:ext cx="12852888" cy="3819525"/>
           </a:xfrm>
           <a:prstGeom prst="rect">
             <a:avLst/>
@@ -3950,10 +3906,10 @@
                 <a:solidFill>
                   <a:srgbClr val="000000"/>
                 </a:solidFill>
-                <a:latin typeface="Jua"/>
-                <a:ea typeface="Jua"/>
-                <a:cs typeface="Jua"/>
-                <a:sym typeface="Jua"/>
+                <a:latin typeface="무궁화 고딕"/>
+                <a:ea typeface="무궁화 고딕"/>
+                <a:cs typeface="무궁화 고딕"/>
+                <a:sym typeface="무궁화 고딕"/>
               </a:rPr>
               <a:t>엄마가 이걸 만지면 항상 울어요</a:t>
             </a:r>
@@ -4050,8 +4006,49 @@
         </p:nvSpPr>
         <p:spPr>
           <a:xfrm rot="0">
-            <a:off x="2717556" y="3895725"/>
-            <a:ext cx="12852888" cy="2200275"/>
+            <a:off x="2717556" y="7762875"/>
+            <a:ext cx="12852888" cy="1466850"/>
+          </a:xfrm>
+          <a:prstGeom prst="rect">
+            <a:avLst/>
+          </a:prstGeom>
+        </p:spPr>
+        <p:txBody>
+          <a:bodyPr anchor="t" rtlCol="false" tIns="0" lIns="0" bIns="0" rIns="0">
+            <a:spAutoFit/>
+          </a:bodyPr>
+          <a:lstStyle/>
+          <a:p>
+            <a:pPr algn="ctr">
+              <a:lnSpc>
+                <a:spcPts val="11520"/>
+              </a:lnSpc>
+            </a:pPr>
+            <a:r>
+              <a:rPr lang="en-US" sz="9600">
+                <a:solidFill>
+                  <a:srgbClr val="7D8AAB"/>
+                </a:solidFill>
+                <a:latin typeface="무궁화 고딕"/>
+                <a:ea typeface="무궁화 고딕"/>
+                <a:cs typeface="무궁화 고딕"/>
+                <a:sym typeface="무궁화 고딕"/>
+              </a:rPr>
+              <a:t>Hint.  까면 까수록 나와요</a:t>
+            </a:r>
+          </a:p>
+        </p:txBody>
+      </p:sp>
+      <p:sp>
+        <p:nvSpPr>
+          <p:cNvPr name="TextBox 5" id="5"/>
+          <p:cNvSpPr txBox="true"/>
+          <p:nvPr/>
+        </p:nvSpPr>
+        <p:spPr>
+          <a:xfrm rot="0">
+            <a:off x="2717556" y="3228975"/>
+            <a:ext cx="12852888" cy="3819525"/>
           </a:xfrm>
           <a:prstGeom prst="rect">
             <a:avLst/>
@@ -4073,12 +4070,12 @@
                 <a:solidFill>
                   <a:srgbClr val="000000"/>
                 </a:solidFill>
-                <a:latin typeface="Jua"/>
-                <a:ea typeface="Jua"/>
-                <a:cs typeface="Jua"/>
-                <a:sym typeface="Jua"/>
+                <a:latin typeface="무궁화 고딕"/>
+                <a:ea typeface="무궁화 고딕"/>
+                <a:cs typeface="무궁화 고딕"/>
+                <a:sym typeface="무궁화 고딕"/>
               </a:rPr>
-              <a:t>양파</a:t>
+              <a:t>엄마가 이걸 만지면 항상 울어요</a:t>
             </a:r>
           </a:p>
         </p:txBody>
@@ -4173,8 +4170,8 @@
         </p:nvSpPr>
         <p:spPr>
           <a:xfrm rot="0">
-            <a:off x="1283793" y="3314700"/>
-            <a:ext cx="15720414" cy="3409950"/>
+            <a:off x="2717556" y="4181475"/>
+            <a:ext cx="12852888" cy="1914525"/>
           </a:xfrm>
           <a:prstGeom prst="rect">
             <a:avLst/>
@@ -4188,20 +4185,20 @@
           <a:p>
             <a:pPr algn="ctr">
               <a:lnSpc>
-                <a:spcPts val="12480"/>
+                <a:spcPts val="15000"/>
               </a:lnSpc>
             </a:pPr>
             <a:r>
-              <a:rPr lang="en-US" sz="10400">
+              <a:rPr lang="en-US" sz="12500">
                 <a:solidFill>
                   <a:srgbClr val="000000"/>
                 </a:solidFill>
-                <a:latin typeface="Jua"/>
-                <a:ea typeface="Jua"/>
-                <a:cs typeface="Jua"/>
-                <a:sym typeface="Jua"/>
+                <a:latin typeface="무궁화 고딕"/>
+                <a:ea typeface="무궁화 고딕"/>
+                <a:cs typeface="무궁화 고딕"/>
+                <a:sym typeface="무궁화 고딕"/>
               </a:rPr>
-              <a:t>줄 잡고 올라가면 하늘이 보이고 내려가면 땅이 보여요</a:t>
+              <a:t>양파</a:t>
             </a:r>
           </a:p>
         </p:txBody>
@@ -4296,8 +4293,8 @@
         </p:nvSpPr>
         <p:spPr>
           <a:xfrm rot="0">
-            <a:off x="2717556" y="7505700"/>
-            <a:ext cx="12852888" cy="1752600"/>
+            <a:off x="1283793" y="3657600"/>
+            <a:ext cx="15720414" cy="2962275"/>
           </a:xfrm>
           <a:prstGeom prst="rect">
             <a:avLst/>
@@ -4311,59 +4308,18 @@
           <a:p>
             <a:pPr algn="ctr">
               <a:lnSpc>
-                <a:spcPts val="11999"/>
+                <a:spcPts val="11640"/>
               </a:lnSpc>
             </a:pPr>
             <a:r>
-              <a:rPr lang="en-US" sz="9999">
-                <a:solidFill>
-                  <a:srgbClr val="7D8AAB"/>
-                </a:solidFill>
-                <a:latin typeface="Jua"/>
-                <a:ea typeface="Jua"/>
-                <a:cs typeface="Jua"/>
-                <a:sym typeface="Jua"/>
-              </a:rPr>
-              <a:t>Hint. 공원에 있어요</a:t>
-            </a:r>
-          </a:p>
-        </p:txBody>
-      </p:sp>
-      <p:sp>
-        <p:nvSpPr>
-          <p:cNvPr name="TextBox 5" id="5"/>
-          <p:cNvSpPr txBox="true"/>
-          <p:nvPr/>
-        </p:nvSpPr>
-        <p:spPr>
-          <a:xfrm rot="0">
-            <a:off x="1283793" y="3314700"/>
-            <a:ext cx="15720414" cy="3409950"/>
-          </a:xfrm>
-          <a:prstGeom prst="rect">
-            <a:avLst/>
-          </a:prstGeom>
-        </p:spPr>
-        <p:txBody>
-          <a:bodyPr anchor="t" rtlCol="false" tIns="0" lIns="0" bIns="0" rIns="0">
-            <a:spAutoFit/>
-          </a:bodyPr>
-          <a:lstStyle/>
-          <a:p>
-            <a:pPr algn="ctr">
-              <a:lnSpc>
-                <a:spcPts val="12480"/>
-              </a:lnSpc>
-            </a:pPr>
-            <a:r>
-              <a:rPr lang="en-US" sz="10400">
+              <a:rPr lang="en-US" sz="9700">
                 <a:solidFill>
                   <a:srgbClr val="000000"/>
                 </a:solidFill>
-                <a:latin typeface="Jua"/>
-                <a:ea typeface="Jua"/>
-                <a:cs typeface="Jua"/>
-                <a:sym typeface="Jua"/>
+                <a:latin typeface="무궁화 고딕"/>
+                <a:ea typeface="무궁화 고딕"/>
+                <a:cs typeface="무궁화 고딕"/>
+                <a:sym typeface="무궁화 고딕"/>
               </a:rPr>
               <a:t>줄 잡고 올라가면 하늘이 보이고 내려가면 땅이 보여요</a:t>
             </a:r>
@@ -4460,8 +4416,8 @@
         </p:nvSpPr>
         <p:spPr>
           <a:xfrm rot="0">
-            <a:off x="2717556" y="3895725"/>
-            <a:ext cx="12852888" cy="2200275"/>
+            <a:off x="2717556" y="7743825"/>
+            <a:ext cx="12852888" cy="1514475"/>
           </a:xfrm>
           <a:prstGeom prst="rect">
             <a:avLst/>
@@ -4475,20 +4431,61 @@
           <a:p>
             <a:pPr algn="ctr">
               <a:lnSpc>
-                <a:spcPts val="15000"/>
+                <a:spcPts val="11999"/>
               </a:lnSpc>
             </a:pPr>
             <a:r>
-              <a:rPr lang="en-US" sz="12500">
+              <a:rPr lang="en-US" sz="9999">
+                <a:solidFill>
+                  <a:srgbClr val="7D8AAB"/>
+                </a:solidFill>
+                <a:latin typeface="무궁화 고딕"/>
+                <a:ea typeface="무궁화 고딕"/>
+                <a:cs typeface="무궁화 고딕"/>
+                <a:sym typeface="무궁화 고딕"/>
+              </a:rPr>
+              <a:t>Hint. 공원에 있어요</a:t>
+            </a:r>
+          </a:p>
+        </p:txBody>
+      </p:sp>
+      <p:sp>
+        <p:nvSpPr>
+          <p:cNvPr name="TextBox 5" id="5"/>
+          <p:cNvSpPr txBox="true"/>
+          <p:nvPr/>
+        </p:nvSpPr>
+        <p:spPr>
+          <a:xfrm rot="0">
+            <a:off x="1283793" y="3657600"/>
+            <a:ext cx="15720414" cy="2962275"/>
+          </a:xfrm>
+          <a:prstGeom prst="rect">
+            <a:avLst/>
+          </a:prstGeom>
+        </p:spPr>
+        <p:txBody>
+          <a:bodyPr anchor="t" rtlCol="false" tIns="0" lIns="0" bIns="0" rIns="0">
+            <a:spAutoFit/>
+          </a:bodyPr>
+          <a:lstStyle/>
+          <a:p>
+            <a:pPr algn="ctr">
+              <a:lnSpc>
+                <a:spcPts val="11640"/>
+              </a:lnSpc>
+            </a:pPr>
+            <a:r>
+              <a:rPr lang="en-US" sz="9700">
                 <a:solidFill>
                   <a:srgbClr val="000000"/>
                 </a:solidFill>
-                <a:latin typeface="Jua"/>
-                <a:ea typeface="Jua"/>
-                <a:cs typeface="Jua"/>
-                <a:sym typeface="Jua"/>
+                <a:latin typeface="무궁화 고딕"/>
+                <a:ea typeface="무궁화 고딕"/>
+                <a:cs typeface="무궁화 고딕"/>
+                <a:sym typeface="무궁화 고딕"/>
               </a:rPr>
-              <a:t>그네</a:t>
+              <a:t>줄 잡고 올라가면 하늘이 보이고 내려가면 땅이 보여요</a:t>
             </a:r>
           </a:p>
         </p:txBody>
@@ -4583,8 +4580,8 @@
         </p:nvSpPr>
         <p:spPr>
           <a:xfrm rot="0">
-            <a:off x="2717556" y="3009900"/>
-            <a:ext cx="12852888" cy="3971925"/>
+            <a:off x="2717556" y="4181475"/>
+            <a:ext cx="12852888" cy="1914525"/>
           </a:xfrm>
           <a:prstGeom prst="rect">
             <a:avLst/>
@@ -4598,20 +4595,20 @@
           <a:p>
             <a:pPr algn="ctr">
               <a:lnSpc>
-                <a:spcPts val="14520"/>
+                <a:spcPts val="15000"/>
               </a:lnSpc>
             </a:pPr>
             <a:r>
-              <a:rPr lang="en-US" sz="12100">
+              <a:rPr lang="en-US" sz="12500">
                 <a:solidFill>
                   <a:srgbClr val="000000"/>
                 </a:solidFill>
-                <a:latin typeface="Jua"/>
-                <a:ea typeface="Jua"/>
-                <a:cs typeface="Jua"/>
-                <a:sym typeface="Jua"/>
+                <a:latin typeface="무궁화 고딕"/>
+                <a:ea typeface="무궁화 고딕"/>
+                <a:cs typeface="무궁화 고딕"/>
+                <a:sym typeface="무궁화 고딕"/>
               </a:rPr>
-              <a:t>안 보이는 벽이 있어서 밖에 나갈 수가 없어요</a:t>
+              <a:t>그네</a:t>
             </a:r>
           </a:p>
         </p:txBody>
@@ -4758,8 +4755,8 @@
         </p:nvSpPr>
         <p:spPr>
           <a:xfrm rot="0">
-            <a:off x="11392761" y="600705"/>
-            <a:ext cx="5362043" cy="1600200"/>
+            <a:off x="11392761" y="819780"/>
+            <a:ext cx="5362043" cy="1381125"/>
           </a:xfrm>
           <a:prstGeom prst="rect">
             <a:avLst/>
@@ -4781,10 +4778,10 @@
                 <a:solidFill>
                   <a:srgbClr val="FFFAEF"/>
                 </a:solidFill>
-                <a:latin typeface="Jua"/>
-                <a:ea typeface="Jua"/>
-                <a:cs typeface="Jua"/>
-                <a:sym typeface="Jua"/>
+                <a:latin typeface="무궁화 고딕"/>
+                <a:ea typeface="무궁화 고딕"/>
+                <a:cs typeface="무궁화 고딕"/>
+                <a:sym typeface="무궁화 고딕"/>
               </a:rPr>
               <a:t>규칙</a:t>
             </a:r>
@@ -4800,9 +4797,9 @@
         <p:grpSpPr>
           <a:xfrm rot="0">
             <a:off x="309172" y="535073"/>
-            <a:ext cx="12619696" cy="2100123"/>
+            <a:ext cx="12619696" cy="1896543"/>
             <a:chOff x="0" y="0"/>
-            <a:chExt cx="16826261" cy="2800164"/>
+            <a:chExt cx="16826261" cy="2528724"/>
           </a:xfrm>
         </p:grpSpPr>
         <p:sp>
@@ -4813,8 +4810,8 @@
           </p:nvSpPr>
           <p:spPr>
             <a:xfrm rot="0">
-              <a:off x="0" y="1615940"/>
-              <a:ext cx="16826261" cy="1184224"/>
+              <a:off x="0" y="1648191"/>
+              <a:ext cx="16826261" cy="880533"/>
             </a:xfrm>
             <a:prstGeom prst="rect">
               <a:avLst/>
@@ -4828,18 +4825,18 @@
             <a:p>
               <a:pPr algn="l">
                 <a:lnSpc>
-                  <a:spcPts val="7402"/>
+                  <a:spcPts val="5599"/>
                 </a:lnSpc>
               </a:pPr>
               <a:r>
-                <a:rPr lang="en-US" sz="5287">
+                <a:rPr lang="en-US" sz="3999">
                   <a:solidFill>
                     <a:srgbClr val="FFFAEF"/>
                   </a:solidFill>
-                  <a:latin typeface="TDTD가온"/>
-                  <a:ea typeface="TDTD가온"/>
-                  <a:cs typeface="TDTD가온"/>
-                  <a:sym typeface="TDTD가온"/>
+                  <a:latin typeface="무궁화 고딕"/>
+                  <a:ea typeface="무궁화 고딕"/>
+                  <a:cs typeface="무궁화 고딕"/>
+                  <a:sym typeface="무궁화 고딕"/>
                 </a:rPr>
                 <a:t>화면에 어린아이가 설명한 문장이 나타납니다.</a:t>
               </a:r>
@@ -4854,8 +4851,8 @@
           </p:nvSpPr>
           <p:spPr>
             <a:xfrm rot="0">
-              <a:off x="0" y="-190500"/>
-              <a:ext cx="11298371" cy="1367863"/>
+              <a:off x="0" y="-66675"/>
+              <a:ext cx="11298371" cy="1238189"/>
             </a:xfrm>
             <a:prstGeom prst="rect">
               <a:avLst/>
@@ -4877,10 +4874,10 @@
                   <a:solidFill>
                     <a:srgbClr val="FFFAEF"/>
                   </a:solidFill>
-                  <a:latin typeface="Jua"/>
-                  <a:ea typeface="Jua"/>
-                  <a:cs typeface="Jua"/>
-                  <a:sym typeface="Jua"/>
+                  <a:latin typeface="무궁화 고딕 Bold"/>
+                  <a:ea typeface="무궁화 고딕 Bold"/>
+                  <a:cs typeface="무궁화 고딕 Bold"/>
+                  <a:sym typeface="무궁화 고딕 Bold"/>
                 </a:rPr>
                 <a:t>STEP 1.</a:t>
               </a:r>
@@ -4896,10 +4893,10 @@
         </p:nvGrpSpPr>
         <p:grpSpPr>
           <a:xfrm rot="0">
-            <a:off x="10181877" y="7319033"/>
-            <a:ext cx="8106123" cy="2967967"/>
+            <a:off x="10763403" y="7312755"/>
+            <a:ext cx="6882913" cy="2543787"/>
             <a:chOff x="0" y="0"/>
-            <a:chExt cx="10808164" cy="3957289"/>
+            <a:chExt cx="9177217" cy="3391716"/>
           </a:xfrm>
         </p:grpSpPr>
         <p:sp>
@@ -4910,8 +4907,8 @@
           </p:nvSpPr>
           <p:spPr>
             <a:xfrm rot="0">
-              <a:off x="0" y="1542808"/>
-              <a:ext cx="10705410" cy="2414482"/>
+              <a:off x="0" y="1571383"/>
+              <a:ext cx="9089968" cy="1820333"/>
             </a:xfrm>
             <a:prstGeom prst="rect">
               <a:avLst/>
@@ -4925,18 +4922,18 @@
             <a:p>
               <a:pPr algn="l">
                 <a:lnSpc>
-                  <a:spcPts val="7420"/>
+                  <a:spcPts val="5599"/>
                 </a:lnSpc>
               </a:pPr>
               <a:r>
-                <a:rPr lang="en-US" sz="5300">
+                <a:rPr lang="en-US" sz="3999">
                   <a:solidFill>
                     <a:srgbClr val="FFFAEF"/>
                   </a:solidFill>
-                  <a:latin typeface="TDTD가온"/>
-                  <a:ea typeface="TDTD가온"/>
-                  <a:cs typeface="TDTD가온"/>
-                  <a:sym typeface="TDTD가온"/>
+                  <a:latin typeface="무궁화 고딕"/>
+                  <a:ea typeface="무궁화 고딕"/>
+                  <a:cs typeface="무궁화 고딕"/>
+                  <a:sym typeface="무궁화 고딕"/>
                 </a:rPr>
                 <a:t>못 맞추면 힌트가 공개됩니다.</a:t>
               </a:r>
@@ -4944,18 +4941,18 @@
             <a:p>
               <a:pPr algn="l">
                 <a:lnSpc>
-                  <a:spcPts val="7420"/>
+                  <a:spcPts val="5599"/>
                 </a:lnSpc>
               </a:pPr>
               <a:r>
-                <a:rPr lang="en-US" sz="5300">
+                <a:rPr lang="en-US" sz="3999">
                   <a:solidFill>
                     <a:srgbClr val="FFFAEF"/>
                   </a:solidFill>
-                  <a:latin typeface="TDTD가온"/>
-                  <a:ea typeface="TDTD가온"/>
-                  <a:cs typeface="TDTD가온"/>
-                  <a:sym typeface="TDTD가온"/>
+                  <a:latin typeface="무궁화 고딕"/>
+                  <a:ea typeface="무궁화 고딕"/>
+                  <a:cs typeface="무궁화 고딕"/>
+                  <a:sym typeface="무궁화 고딕"/>
                 </a:rPr>
                 <a:t>가장 많은 점수를 얻은 팀이 우승!</a:t>
               </a:r>
@@ -4970,8 +4967,8 @@
           </p:nvSpPr>
           <p:spPr>
             <a:xfrm rot="0">
-              <a:off x="0" y="-190500"/>
-              <a:ext cx="10808164" cy="1374479"/>
+              <a:off x="0" y="-57150"/>
+              <a:ext cx="9177217" cy="1241129"/>
             </a:xfrm>
             <a:prstGeom prst="rect">
               <a:avLst/>
@@ -4993,10 +4990,10 @@
                   <a:solidFill>
                     <a:srgbClr val="FFFAEF"/>
                   </a:solidFill>
-                  <a:latin typeface="Jua"/>
-                  <a:ea typeface="Jua"/>
-                  <a:cs typeface="Jua"/>
-                  <a:sym typeface="Jua"/>
+                  <a:latin typeface="무궁화 고딕 Bold"/>
+                  <a:ea typeface="무궁화 고딕 Bold"/>
+                  <a:cs typeface="무궁화 고딕 Bold"/>
+                  <a:sym typeface="무궁화 고딕 Bold"/>
                 </a:rPr>
                 <a:t>STEP 3.</a:t>
               </a:r>
@@ -5012,10 +5009,10 @@
         </p:nvGrpSpPr>
         <p:grpSpPr>
           <a:xfrm rot="0">
-            <a:off x="5144447" y="3458624"/>
-            <a:ext cx="7054922" cy="3036981"/>
+            <a:off x="5304868" y="3573770"/>
+            <a:ext cx="7054922" cy="2596832"/>
             <a:chOff x="0" y="0"/>
-            <a:chExt cx="9406563" cy="4049308"/>
+            <a:chExt cx="9406563" cy="3462442"/>
           </a:xfrm>
         </p:grpSpPr>
         <p:sp>
@@ -5026,8 +5023,8 @@
           </p:nvSpPr>
           <p:spPr>
             <a:xfrm rot="0">
-              <a:off x="0" y="1621596"/>
-              <a:ext cx="9406563" cy="2427712"/>
+              <a:off x="0" y="1642109"/>
+              <a:ext cx="9406563" cy="1820333"/>
             </a:xfrm>
             <a:prstGeom prst="rect">
               <a:avLst/>
@@ -5041,18 +5038,18 @@
             <a:p>
               <a:pPr algn="l">
                 <a:lnSpc>
-                  <a:spcPts val="7415"/>
+                  <a:spcPts val="5599"/>
                 </a:lnSpc>
               </a:pPr>
               <a:r>
-                <a:rPr lang="en-US" sz="5296">
+                <a:rPr lang="en-US" sz="3999">
                   <a:solidFill>
                     <a:srgbClr val="FFFAEF"/>
                   </a:solidFill>
-                  <a:latin typeface="TDTD가온"/>
-                  <a:ea typeface="TDTD가온"/>
-                  <a:cs typeface="TDTD가온"/>
-                  <a:sym typeface="TDTD가온"/>
+                  <a:latin typeface="무궁화 고딕"/>
+                  <a:ea typeface="무궁화 고딕"/>
+                  <a:cs typeface="무궁화 고딕"/>
+                  <a:sym typeface="무궁화 고딕"/>
                 </a:rPr>
                 <a:t>팀별로 동시에 보고 가장 먼저</a:t>
               </a:r>
@@ -5060,18 +5057,18 @@
             <a:p>
               <a:pPr algn="l">
                 <a:lnSpc>
-                  <a:spcPts val="7415"/>
+                  <a:spcPts val="5599"/>
                 </a:lnSpc>
               </a:pPr>
               <a:r>
-                <a:rPr lang="en-US" sz="5296">
+                <a:rPr lang="en-US" sz="3999">
                   <a:solidFill>
                     <a:srgbClr val="FFFAEF"/>
                   </a:solidFill>
-                  <a:latin typeface="TDTD가온"/>
-                  <a:ea typeface="TDTD가온"/>
-                  <a:cs typeface="TDTD가온"/>
-                  <a:sym typeface="TDTD가온"/>
+                  <a:latin typeface="무궁화 고딕"/>
+                  <a:ea typeface="무궁화 고딕"/>
+                  <a:cs typeface="무궁화 고딕"/>
+                  <a:sym typeface="무궁화 고딕"/>
                 </a:rPr>
                 <a:t>정답을 외치세요!</a:t>
               </a:r>
@@ -5086,8 +5083,8 @@
           </p:nvSpPr>
           <p:spPr>
             <a:xfrm rot="0">
-              <a:off x="0" y="-190500"/>
-              <a:ext cx="5799240" cy="1369906"/>
+              <a:off x="0" y="-66675"/>
+              <a:ext cx="5799240" cy="1238018"/>
             </a:xfrm>
             <a:prstGeom prst="rect">
               <a:avLst/>
@@ -5109,10 +5106,10 @@
                   <a:solidFill>
                     <a:srgbClr val="FFFAEF"/>
                   </a:solidFill>
-                  <a:latin typeface="Jua"/>
-                  <a:ea typeface="Jua"/>
-                  <a:cs typeface="Jua"/>
-                  <a:sym typeface="Jua"/>
+                  <a:latin typeface="무궁화 고딕 Bold"/>
+                  <a:ea typeface="무궁화 고딕 Bold"/>
+                  <a:cs typeface="무궁화 고딕 Bold"/>
+                  <a:sym typeface="무궁화 고딕 Bold"/>
                 </a:rPr>
                 <a:t>STEP 2.</a:t>
               </a:r>
@@ -5210,8 +5207,8 @@
         </p:nvSpPr>
         <p:spPr>
           <a:xfrm rot="0">
-            <a:off x="2717556" y="7505700"/>
-            <a:ext cx="12852888" cy="1752600"/>
+            <a:off x="2717556" y="3419475"/>
+            <a:ext cx="12852888" cy="3438525"/>
           </a:xfrm>
           <a:prstGeom prst="rect">
             <a:avLst/>
@@ -5225,59 +5222,18 @@
           <a:p>
             <a:pPr algn="ctr">
               <a:lnSpc>
-                <a:spcPts val="11999"/>
+                <a:spcPts val="13560"/>
               </a:lnSpc>
             </a:pPr>
             <a:r>
-              <a:rPr lang="en-US" sz="9999">
-                <a:solidFill>
-                  <a:srgbClr val="7D8AAB"/>
-                </a:solidFill>
-                <a:latin typeface="Jua"/>
-                <a:ea typeface="Jua"/>
-                <a:cs typeface="Jua"/>
-                <a:sym typeface="Jua"/>
-              </a:rPr>
-              <a:t>Hint. 새도 부딪혀요</a:t>
-            </a:r>
-          </a:p>
-        </p:txBody>
-      </p:sp>
-      <p:sp>
-        <p:nvSpPr>
-          <p:cNvPr name="TextBox 5" id="5"/>
-          <p:cNvSpPr txBox="true"/>
-          <p:nvPr/>
-        </p:nvSpPr>
-        <p:spPr>
-          <a:xfrm rot="0">
-            <a:off x="2717556" y="3009900"/>
-            <a:ext cx="12852888" cy="3971925"/>
-          </a:xfrm>
-          <a:prstGeom prst="rect">
-            <a:avLst/>
-          </a:prstGeom>
-        </p:spPr>
-        <p:txBody>
-          <a:bodyPr anchor="t" rtlCol="false" tIns="0" lIns="0" bIns="0" rIns="0">
-            <a:spAutoFit/>
-          </a:bodyPr>
-          <a:lstStyle/>
-          <a:p>
-            <a:pPr algn="ctr">
-              <a:lnSpc>
-                <a:spcPts val="14520"/>
-              </a:lnSpc>
-            </a:pPr>
-            <a:r>
-              <a:rPr lang="en-US" sz="12100">
+              <a:rPr lang="en-US" sz="11300">
                 <a:solidFill>
                   <a:srgbClr val="000000"/>
                 </a:solidFill>
-                <a:latin typeface="Jua"/>
-                <a:ea typeface="Jua"/>
-                <a:cs typeface="Jua"/>
-                <a:sym typeface="Jua"/>
+                <a:latin typeface="무궁화 고딕"/>
+                <a:ea typeface="무궁화 고딕"/>
+                <a:cs typeface="무궁화 고딕"/>
+                <a:sym typeface="무궁화 고딕"/>
               </a:rPr>
               <a:t>안 보이는 벽이 있어서 밖에 나갈 수가 없어요</a:t>
             </a:r>
@@ -5374,8 +5330,8 @@
         </p:nvSpPr>
         <p:spPr>
           <a:xfrm rot="0">
-            <a:off x="2717556" y="3895725"/>
-            <a:ext cx="12852888" cy="2200275"/>
+            <a:off x="2717556" y="7743825"/>
+            <a:ext cx="12852888" cy="1514475"/>
           </a:xfrm>
           <a:prstGeom prst="rect">
             <a:avLst/>
@@ -5389,20 +5345,61 @@
           <a:p>
             <a:pPr algn="ctr">
               <a:lnSpc>
-                <a:spcPts val="15000"/>
+                <a:spcPts val="11999"/>
               </a:lnSpc>
             </a:pPr>
             <a:r>
-              <a:rPr lang="en-US" sz="12500">
+              <a:rPr lang="en-US" sz="9999">
+                <a:solidFill>
+                  <a:srgbClr val="7D8AAB"/>
+                </a:solidFill>
+                <a:latin typeface="무궁화 고딕"/>
+                <a:ea typeface="무궁화 고딕"/>
+                <a:cs typeface="무궁화 고딕"/>
+                <a:sym typeface="무궁화 고딕"/>
+              </a:rPr>
+              <a:t>Hint. 새도 부딪혀요</a:t>
+            </a:r>
+          </a:p>
+        </p:txBody>
+      </p:sp>
+      <p:sp>
+        <p:nvSpPr>
+          <p:cNvPr name="TextBox 5" id="5"/>
+          <p:cNvSpPr txBox="true"/>
+          <p:nvPr/>
+        </p:nvSpPr>
+        <p:spPr>
+          <a:xfrm rot="0">
+            <a:off x="2717556" y="3419475"/>
+            <a:ext cx="12852888" cy="3438525"/>
+          </a:xfrm>
+          <a:prstGeom prst="rect">
+            <a:avLst/>
+          </a:prstGeom>
+        </p:spPr>
+        <p:txBody>
+          <a:bodyPr anchor="t" rtlCol="false" tIns="0" lIns="0" bIns="0" rIns="0">
+            <a:spAutoFit/>
+          </a:bodyPr>
+          <a:lstStyle/>
+          <a:p>
+            <a:pPr algn="ctr">
+              <a:lnSpc>
+                <a:spcPts val="13560"/>
+              </a:lnSpc>
+            </a:pPr>
+            <a:r>
+              <a:rPr lang="en-US" sz="11300">
                 <a:solidFill>
                   <a:srgbClr val="000000"/>
                 </a:solidFill>
-                <a:latin typeface="Jua"/>
-                <a:ea typeface="Jua"/>
-                <a:cs typeface="Jua"/>
-                <a:sym typeface="Jua"/>
+                <a:latin typeface="무궁화 고딕"/>
+                <a:ea typeface="무궁화 고딕"/>
+                <a:cs typeface="무궁화 고딕"/>
+                <a:sym typeface="무궁화 고딕"/>
               </a:rPr>
-              <a:t>유리문</a:t>
+              <a:t>안 보이는 벽이 있어서 밖에 나갈 수가 없어요</a:t>
             </a:r>
           </a:p>
         </p:txBody>
@@ -5497,8 +5494,8 @@
         </p:nvSpPr>
         <p:spPr>
           <a:xfrm rot="0">
-            <a:off x="2717556" y="3171825"/>
-            <a:ext cx="12852888" cy="3676650"/>
+            <a:off x="2717556" y="4181475"/>
+            <a:ext cx="12852888" cy="1914525"/>
           </a:xfrm>
           <a:prstGeom prst="rect">
             <a:avLst/>
@@ -5512,20 +5509,20 @@
           <a:p>
             <a:pPr algn="ctr">
               <a:lnSpc>
-                <a:spcPts val="13440"/>
+                <a:spcPts val="15000"/>
               </a:lnSpc>
             </a:pPr>
             <a:r>
-              <a:rPr lang="en-US" sz="11200">
+              <a:rPr lang="en-US" sz="12500">
                 <a:solidFill>
                   <a:srgbClr val="000000"/>
                 </a:solidFill>
-                <a:latin typeface="Jua"/>
-                <a:ea typeface="Jua"/>
-                <a:cs typeface="Jua"/>
-                <a:sym typeface="Jua"/>
+                <a:latin typeface="무궁화 고딕"/>
+                <a:ea typeface="무궁화 고딕"/>
+                <a:cs typeface="무궁화 고딕"/>
+                <a:sym typeface="무궁화 고딕"/>
               </a:rPr>
-              <a:t>아빠가 검은 물을 마시면 눈이 커져요</a:t>
+              <a:t>유리문</a:t>
             </a:r>
           </a:p>
         </p:txBody>
@@ -5620,8 +5617,8 @@
         </p:nvSpPr>
         <p:spPr>
           <a:xfrm rot="0">
-            <a:off x="2717556" y="7591425"/>
-            <a:ext cx="12852888" cy="1600200"/>
+            <a:off x="2717556" y="3552825"/>
+            <a:ext cx="12852888" cy="3171825"/>
           </a:xfrm>
           <a:prstGeom prst="rect">
             <a:avLst/>
@@ -5635,59 +5632,18 @@
           <a:p>
             <a:pPr algn="ctr">
               <a:lnSpc>
-                <a:spcPts val="10920"/>
+                <a:spcPts val="12480"/>
               </a:lnSpc>
             </a:pPr>
             <a:r>
-              <a:rPr lang="en-US" sz="9100">
-                <a:solidFill>
-                  <a:srgbClr val="7D8AAB"/>
-                </a:solidFill>
-                <a:latin typeface="Jua"/>
-                <a:ea typeface="Jua"/>
-                <a:cs typeface="Jua"/>
-                <a:sym typeface="Jua"/>
-              </a:rPr>
-              <a:t>Hint. 근데 어른들이 좋아해요</a:t>
-            </a:r>
-          </a:p>
-        </p:txBody>
-      </p:sp>
-      <p:sp>
-        <p:nvSpPr>
-          <p:cNvPr name="TextBox 5" id="5"/>
-          <p:cNvSpPr txBox="true"/>
-          <p:nvPr/>
-        </p:nvSpPr>
-        <p:spPr>
-          <a:xfrm rot="0">
-            <a:off x="2717556" y="3171825"/>
-            <a:ext cx="12852888" cy="3676650"/>
-          </a:xfrm>
-          <a:prstGeom prst="rect">
-            <a:avLst/>
-          </a:prstGeom>
-        </p:spPr>
-        <p:txBody>
-          <a:bodyPr anchor="t" rtlCol="false" tIns="0" lIns="0" bIns="0" rIns="0">
-            <a:spAutoFit/>
-          </a:bodyPr>
-          <a:lstStyle/>
-          <a:p>
-            <a:pPr algn="ctr">
-              <a:lnSpc>
-                <a:spcPts val="13440"/>
-              </a:lnSpc>
-            </a:pPr>
-            <a:r>
-              <a:rPr lang="en-US" sz="11200">
+              <a:rPr lang="en-US" sz="10400">
                 <a:solidFill>
                   <a:srgbClr val="000000"/>
                 </a:solidFill>
-                <a:latin typeface="Jua"/>
-                <a:ea typeface="Jua"/>
-                <a:cs typeface="Jua"/>
-                <a:sym typeface="Jua"/>
+                <a:latin typeface="무궁화 고딕"/>
+                <a:ea typeface="무궁화 고딕"/>
+                <a:cs typeface="무궁화 고딕"/>
+                <a:sym typeface="무궁화 고딕"/>
               </a:rPr>
               <a:t>아빠가 검은 물을 마시면 눈이 커져요</a:t>
             </a:r>
@@ -5784,8 +5740,8 @@
         </p:nvSpPr>
         <p:spPr>
           <a:xfrm rot="0">
-            <a:off x="2717556" y="3895725"/>
-            <a:ext cx="12852888" cy="2200275"/>
+            <a:off x="2717556" y="7853363"/>
+            <a:ext cx="12852888" cy="1285875"/>
           </a:xfrm>
           <a:prstGeom prst="rect">
             <a:avLst/>
@@ -5799,20 +5755,61 @@
           <a:p>
             <a:pPr algn="ctr">
               <a:lnSpc>
-                <a:spcPts val="15000"/>
+                <a:spcPts val="10080"/>
               </a:lnSpc>
             </a:pPr>
             <a:r>
-              <a:rPr lang="en-US" sz="12500">
+              <a:rPr lang="en-US" sz="8400">
+                <a:solidFill>
+                  <a:srgbClr val="7D8AAB"/>
+                </a:solidFill>
+                <a:latin typeface="무궁화 고딕"/>
+                <a:ea typeface="무궁화 고딕"/>
+                <a:cs typeface="무궁화 고딕"/>
+                <a:sym typeface="무궁화 고딕"/>
+              </a:rPr>
+              <a:t>Hint. 근데 어른들이 좋아해요</a:t>
+            </a:r>
+          </a:p>
+        </p:txBody>
+      </p:sp>
+      <p:sp>
+        <p:nvSpPr>
+          <p:cNvPr name="TextBox 5" id="5"/>
+          <p:cNvSpPr txBox="true"/>
+          <p:nvPr/>
+        </p:nvSpPr>
+        <p:spPr>
+          <a:xfrm rot="0">
+            <a:off x="2717556" y="3552825"/>
+            <a:ext cx="12852888" cy="3171825"/>
+          </a:xfrm>
+          <a:prstGeom prst="rect">
+            <a:avLst/>
+          </a:prstGeom>
+        </p:spPr>
+        <p:txBody>
+          <a:bodyPr anchor="t" rtlCol="false" tIns="0" lIns="0" bIns="0" rIns="0">
+            <a:spAutoFit/>
+          </a:bodyPr>
+          <a:lstStyle/>
+          <a:p>
+            <a:pPr algn="ctr">
+              <a:lnSpc>
+                <a:spcPts val="12480"/>
+              </a:lnSpc>
+            </a:pPr>
+            <a:r>
+              <a:rPr lang="en-US" sz="10400">
                 <a:solidFill>
                   <a:srgbClr val="000000"/>
                 </a:solidFill>
-                <a:latin typeface="Jua"/>
-                <a:ea typeface="Jua"/>
-                <a:cs typeface="Jua"/>
-                <a:sym typeface="Jua"/>
+                <a:latin typeface="무궁화 고딕"/>
+                <a:ea typeface="무궁화 고딕"/>
+                <a:cs typeface="무궁화 고딕"/>
+                <a:sym typeface="무궁화 고딕"/>
               </a:rPr>
-              <a:t>커피</a:t>
+              <a:t>아빠가 검은 물을 마시면 눈이 커져요</a:t>
             </a:r>
           </a:p>
         </p:txBody>
@@ -5907,8 +5904,8 @@
         </p:nvSpPr>
         <p:spPr>
           <a:xfrm rot="0">
-            <a:off x="2717556" y="3171825"/>
-            <a:ext cx="12852888" cy="3676650"/>
+            <a:off x="2717556" y="4181475"/>
+            <a:ext cx="12852888" cy="1914525"/>
           </a:xfrm>
           <a:prstGeom prst="rect">
             <a:avLst/>
@@ -5922,20 +5919,20 @@
           <a:p>
             <a:pPr algn="ctr">
               <a:lnSpc>
-                <a:spcPts val="13440"/>
+                <a:spcPts val="15000"/>
               </a:lnSpc>
             </a:pPr>
             <a:r>
-              <a:rPr lang="en-US" sz="11200">
+              <a:rPr lang="en-US" sz="12500">
                 <a:solidFill>
                   <a:srgbClr val="000000"/>
                 </a:solidFill>
-                <a:latin typeface="Jua"/>
-                <a:ea typeface="Jua"/>
-                <a:cs typeface="Jua"/>
-                <a:sym typeface="Jua"/>
+                <a:latin typeface="무궁화 고딕"/>
+                <a:ea typeface="무궁화 고딕"/>
+                <a:cs typeface="무궁화 고딕"/>
+                <a:sym typeface="무궁화 고딕"/>
               </a:rPr>
-              <a:t>엄마가 세모 모자 씌우고 불 끄라고 해요</a:t>
+              <a:t>커피</a:t>
             </a:r>
           </a:p>
         </p:txBody>
@@ -6030,8 +6027,8 @@
         </p:nvSpPr>
         <p:spPr>
           <a:xfrm rot="0">
-            <a:off x="2717556" y="7558087"/>
-            <a:ext cx="12852888" cy="1666875"/>
+            <a:off x="2717556" y="3533775"/>
+            <a:ext cx="12852888" cy="3209925"/>
           </a:xfrm>
           <a:prstGeom prst="rect">
             <a:avLst/>
@@ -6045,59 +6042,18 @@
           <a:p>
             <a:pPr algn="ctr">
               <a:lnSpc>
-                <a:spcPts val="11400"/>
+                <a:spcPts val="12600"/>
               </a:lnSpc>
             </a:pPr>
             <a:r>
-              <a:rPr lang="en-US" sz="9500">
-                <a:solidFill>
-                  <a:srgbClr val="7D8AAB"/>
-                </a:solidFill>
-                <a:latin typeface="Jua"/>
-                <a:ea typeface="Jua"/>
-                <a:cs typeface="Jua"/>
-                <a:sym typeface="Jua"/>
-              </a:rPr>
-              <a:t>Hint. 노래 부르고 나서 해요</a:t>
-            </a:r>
-          </a:p>
-        </p:txBody>
-      </p:sp>
-      <p:sp>
-        <p:nvSpPr>
-          <p:cNvPr name="TextBox 5" id="5"/>
-          <p:cNvSpPr txBox="true"/>
-          <p:nvPr/>
-        </p:nvSpPr>
-        <p:spPr>
-          <a:xfrm rot="0">
-            <a:off x="2717556" y="3171825"/>
-            <a:ext cx="12852888" cy="3676650"/>
-          </a:xfrm>
-          <a:prstGeom prst="rect">
-            <a:avLst/>
-          </a:prstGeom>
-        </p:spPr>
-        <p:txBody>
-          <a:bodyPr anchor="t" rtlCol="false" tIns="0" lIns="0" bIns="0" rIns="0">
-            <a:spAutoFit/>
-          </a:bodyPr>
-          <a:lstStyle/>
-          <a:p>
-            <a:pPr algn="ctr">
-              <a:lnSpc>
-                <a:spcPts val="13440"/>
-              </a:lnSpc>
-            </a:pPr>
-            <a:r>
-              <a:rPr lang="en-US" sz="11200">
+              <a:rPr lang="en-US" sz="10500">
                 <a:solidFill>
                   <a:srgbClr val="000000"/>
                 </a:solidFill>
-                <a:latin typeface="Jua"/>
-                <a:ea typeface="Jua"/>
-                <a:cs typeface="Jua"/>
-                <a:sym typeface="Jua"/>
+                <a:latin typeface="무궁화 고딕"/>
+                <a:ea typeface="무궁화 고딕"/>
+                <a:cs typeface="무궁화 고딕"/>
+                <a:sym typeface="무궁화 고딕"/>
               </a:rPr>
               <a:t>엄마가 세모 모자 씌우고 불 끄라고 해요</a:t>
             </a:r>
@@ -6194,8 +6150,8 @@
         </p:nvSpPr>
         <p:spPr>
           <a:xfrm rot="0">
-            <a:off x="2717556" y="3895725"/>
-            <a:ext cx="12852888" cy="2200275"/>
+            <a:off x="2717556" y="7815263"/>
+            <a:ext cx="12852888" cy="1362075"/>
           </a:xfrm>
           <a:prstGeom prst="rect">
             <a:avLst/>
@@ -6209,20 +6165,61 @@
           <a:p>
             <a:pPr algn="ctr">
               <a:lnSpc>
-                <a:spcPts val="15000"/>
+                <a:spcPts val="10680"/>
               </a:lnSpc>
             </a:pPr>
             <a:r>
-              <a:rPr lang="en-US" sz="12500">
+              <a:rPr lang="en-US" sz="8900">
+                <a:solidFill>
+                  <a:srgbClr val="7D8AAB"/>
+                </a:solidFill>
+                <a:latin typeface="무궁화 고딕"/>
+                <a:ea typeface="무궁화 고딕"/>
+                <a:cs typeface="무궁화 고딕"/>
+                <a:sym typeface="무궁화 고딕"/>
+              </a:rPr>
+              <a:t>Hint. 노래 부르고 나서 해요</a:t>
+            </a:r>
+          </a:p>
+        </p:txBody>
+      </p:sp>
+      <p:sp>
+        <p:nvSpPr>
+          <p:cNvPr name="TextBox 5" id="5"/>
+          <p:cNvSpPr txBox="true"/>
+          <p:nvPr/>
+        </p:nvSpPr>
+        <p:spPr>
+          <a:xfrm rot="0">
+            <a:off x="2717556" y="3533775"/>
+            <a:ext cx="12852888" cy="3209925"/>
+          </a:xfrm>
+          <a:prstGeom prst="rect">
+            <a:avLst/>
+          </a:prstGeom>
+        </p:spPr>
+        <p:txBody>
+          <a:bodyPr anchor="t" rtlCol="false" tIns="0" lIns="0" bIns="0" rIns="0">
+            <a:spAutoFit/>
+          </a:bodyPr>
+          <a:lstStyle/>
+          <a:p>
+            <a:pPr algn="ctr">
+              <a:lnSpc>
+                <a:spcPts val="12600"/>
+              </a:lnSpc>
+            </a:pPr>
+            <a:r>
+              <a:rPr lang="en-US" sz="10500">
                 <a:solidFill>
                   <a:srgbClr val="000000"/>
                 </a:solidFill>
-                <a:latin typeface="Jua"/>
-                <a:ea typeface="Jua"/>
-                <a:cs typeface="Jua"/>
-                <a:sym typeface="Jua"/>
+                <a:latin typeface="무궁화 고딕"/>
+                <a:ea typeface="무궁화 고딕"/>
+                <a:cs typeface="무궁화 고딕"/>
+                <a:sym typeface="무궁화 고딕"/>
               </a:rPr>
-              <a:t>생일 케이크</a:t>
+              <a:t>엄마가 세모 모자 씌우고 불 끄라고 해요</a:t>
             </a:r>
           </a:p>
         </p:txBody>
@@ -6317,8 +6314,8 @@
         </p:nvSpPr>
         <p:spPr>
           <a:xfrm rot="0">
-            <a:off x="2196188" y="3371850"/>
-            <a:ext cx="13895624" cy="3295650"/>
+            <a:off x="2717556" y="4181475"/>
+            <a:ext cx="12852888" cy="1914525"/>
           </a:xfrm>
           <a:prstGeom prst="rect">
             <a:avLst/>
@@ -6332,20 +6329,20 @@
           <a:p>
             <a:pPr algn="ctr">
               <a:lnSpc>
-                <a:spcPts val="12000"/>
+                <a:spcPts val="15000"/>
               </a:lnSpc>
             </a:pPr>
             <a:r>
-              <a:rPr lang="en-US" sz="10000">
+              <a:rPr lang="en-US" sz="12500">
                 <a:solidFill>
                   <a:srgbClr val="000000"/>
                 </a:solidFill>
-                <a:latin typeface="Jua"/>
-                <a:ea typeface="Jua"/>
-                <a:cs typeface="Jua"/>
-                <a:sym typeface="Jua"/>
+                <a:latin typeface="무궁화 고딕"/>
+                <a:ea typeface="무궁화 고딕"/>
+                <a:cs typeface="무궁화 고딕"/>
+                <a:sym typeface="무궁화 고딕"/>
               </a:rPr>
-              <a:t>큰 새가 하늘에서 안 움직이고 가만히 있어요</a:t>
+              <a:t>생일 케이크</a:t>
             </a:r>
           </a:p>
         </p:txBody>
@@ -6440,8 +6437,8 @@
         </p:nvSpPr>
         <p:spPr>
           <a:xfrm rot="0">
-            <a:off x="2717556" y="7505700"/>
-            <a:ext cx="12852888" cy="1752600"/>
+            <a:off x="2196188" y="3724275"/>
+            <a:ext cx="13895624" cy="2828925"/>
           </a:xfrm>
           <a:prstGeom prst="rect">
             <a:avLst/>
@@ -6455,59 +6452,18 @@
           <a:p>
             <a:pPr algn="ctr">
               <a:lnSpc>
-                <a:spcPts val="11999"/>
+                <a:spcPts val="11160"/>
               </a:lnSpc>
             </a:pPr>
             <a:r>
-              <a:rPr lang="en-US" sz="9999">
-                <a:solidFill>
-                  <a:srgbClr val="7D8AAB"/>
-                </a:solidFill>
-                <a:latin typeface="Jua"/>
-                <a:ea typeface="Jua"/>
-                <a:cs typeface="Jua"/>
-                <a:sym typeface="Jua"/>
-              </a:rPr>
-              <a:t>Hint. 사람이 타고 있어요</a:t>
-            </a:r>
-          </a:p>
-        </p:txBody>
-      </p:sp>
-      <p:sp>
-        <p:nvSpPr>
-          <p:cNvPr name="TextBox 5" id="5"/>
-          <p:cNvSpPr txBox="true"/>
-          <p:nvPr/>
-        </p:nvSpPr>
-        <p:spPr>
-          <a:xfrm rot="0">
-            <a:off x="2196188" y="3371850"/>
-            <a:ext cx="13895624" cy="3295650"/>
-          </a:xfrm>
-          <a:prstGeom prst="rect">
-            <a:avLst/>
-          </a:prstGeom>
-        </p:spPr>
-        <p:txBody>
-          <a:bodyPr anchor="t" rtlCol="false" tIns="0" lIns="0" bIns="0" rIns="0">
-            <a:spAutoFit/>
-          </a:bodyPr>
-          <a:lstStyle/>
-          <a:p>
-            <a:pPr algn="ctr">
-              <a:lnSpc>
-                <a:spcPts val="12000"/>
-              </a:lnSpc>
-            </a:pPr>
-            <a:r>
-              <a:rPr lang="en-US" sz="10000">
+              <a:rPr lang="en-US" sz="9300">
                 <a:solidFill>
                   <a:srgbClr val="000000"/>
                 </a:solidFill>
-                <a:latin typeface="Jua"/>
-                <a:ea typeface="Jua"/>
-                <a:cs typeface="Jua"/>
-                <a:sym typeface="Jua"/>
+                <a:latin typeface="무궁화 고딕"/>
+                <a:ea typeface="무궁화 고딕"/>
+                <a:cs typeface="무궁화 고딕"/>
+                <a:sym typeface="무궁화 고딕"/>
               </a:rPr>
               <a:t>큰 새가 하늘에서 안 움직이고 가만히 있어요</a:t>
             </a:r>
@@ -6528,7 +6484,7 @@
     <p:bg>
       <p:bgPr>
         <a:solidFill>
-          <a:srgbClr val="7D8AAB"/>
+          <a:srgbClr val="FFFAEF"/>
         </a:solidFill>
       </p:bgPr>
     </p:bg>
@@ -6546,9 +6502,50 @@
           <a:chExt cx="0" cy="0"/>
         </a:xfrm>
       </p:grpSpPr>
+      <p:sp>
+        <p:nvSpPr>
+          <p:cNvPr name="TextBox 2" id="2"/>
+          <p:cNvSpPr txBox="true"/>
+          <p:nvPr/>
+        </p:nvSpPr>
+        <p:spPr>
+          <a:xfrm rot="0">
+            <a:off x="3238925" y="4378545"/>
+            <a:ext cx="11810151" cy="1914525"/>
+          </a:xfrm>
+          <a:prstGeom prst="rect">
+            <a:avLst/>
+          </a:prstGeom>
+        </p:spPr>
+        <p:txBody>
+          <a:bodyPr anchor="t" rtlCol="false" tIns="0" lIns="0" bIns="0" rIns="0">
+            <a:spAutoFit/>
+          </a:bodyPr>
+          <a:lstStyle/>
+          <a:p>
+            <a:pPr algn="ctr">
+              <a:lnSpc>
+                <a:spcPts val="15000"/>
+              </a:lnSpc>
+            </a:pPr>
+            <a:r>
+              <a:rPr lang="en-US" sz="12500">
+                <a:solidFill>
+                  <a:srgbClr val="000000"/>
+                </a:solidFill>
+                <a:latin typeface="무궁화 고딕"/>
+                <a:ea typeface="무궁화 고딕"/>
+                <a:cs typeface="무궁화 고딕"/>
+                <a:sym typeface="무궁화 고딕"/>
+              </a:rPr>
+              <a:t>팀을 나눠주세요!</a:t>
+            </a:r>
+          </a:p>
+        </p:txBody>
+      </p:sp>
       <p:pic>
         <p:nvPicPr>
-          <p:cNvPr name="Picture 2" id="2"/>
+          <p:cNvPr name="Picture 3" id="3"/>
           <p:cNvPicPr>
             <a:picLocks noChangeAspect="true"/>
           </p:cNvPicPr>
@@ -6556,15 +6553,15 @@
         </p:nvPicPr>
         <p:blipFill>
           <a:blip r:embed="rId2"/>
-          <a:srcRect l="64771" t="21970" r="0" b="0"/>
+          <a:srcRect l="0" t="0" r="0" b="0"/>
           <a:stretch>
             <a:fillRect/>
           </a:stretch>
         </p:blipFill>
         <p:spPr>
-          <a:xfrm flipH="false" flipV="false" rot="5400000">
-            <a:off x="2310738" y="4172522"/>
-            <a:ext cx="3803740" cy="8425216"/>
+          <a:xfrm flipH="false" flipV="false" rot="0">
+            <a:off x="13655377" y="6809666"/>
+            <a:ext cx="6229999" cy="6954669"/>
           </a:xfrm>
           <a:prstGeom prst="rect">
             <a:avLst/>
@@ -6573,7 +6570,7 @@
       </p:pic>
       <p:pic>
         <p:nvPicPr>
-          <p:cNvPr name="Picture 3" id="3"/>
+          <p:cNvPr name="Picture 4" id="4"/>
           <p:cNvPicPr>
             <a:picLocks noChangeAspect="true"/>
           </p:cNvPicPr>
@@ -6587,100 +6584,15 @@
           </a:stretch>
         </p:blipFill>
         <p:spPr>
-          <a:xfrm flipH="false" flipV="false" rot="-7094170">
-            <a:off x="14148180" y="-2590072"/>
-            <a:ext cx="7036829" cy="7237544"/>
+          <a:xfrm flipH="false" flipV="false" rot="0">
+            <a:off x="0" y="0"/>
+            <a:ext cx="6925457" cy="4700654"/>
           </a:xfrm>
           <a:prstGeom prst="rect">
             <a:avLst/>
           </a:prstGeom>
         </p:spPr>
       </p:pic>
-      <p:sp>
-        <p:nvSpPr>
-          <p:cNvPr name="TextBox 4" id="4"/>
-          <p:cNvSpPr txBox="true"/>
-          <p:nvPr/>
-        </p:nvSpPr>
-        <p:spPr>
-          <a:xfrm rot="0">
-            <a:off x="1028700" y="3892867"/>
-            <a:ext cx="15555091" cy="2200275"/>
-          </a:xfrm>
-          <a:prstGeom prst="rect">
-            <a:avLst/>
-          </a:prstGeom>
-        </p:spPr>
-        <p:txBody>
-          <a:bodyPr anchor="t" rtlCol="false" tIns="0" lIns="0" bIns="0" rIns="0">
-            <a:spAutoFit/>
-          </a:bodyPr>
-          <a:lstStyle/>
-          <a:p>
-            <a:pPr algn="ctr">
-              <a:lnSpc>
-                <a:spcPts val="15000"/>
-              </a:lnSpc>
-            </a:pPr>
-            <a:r>
-              <a:rPr lang="en-US" sz="12500">
-                <a:solidFill>
-                  <a:srgbClr val="FFFAEF"/>
-                </a:solidFill>
-                <a:latin typeface="Jua"/>
-                <a:ea typeface="Jua"/>
-                <a:cs typeface="Jua"/>
-                <a:sym typeface="Jua"/>
-              </a:rPr>
-              <a:t>눈높이 퀴즈</a:t>
-            </a:r>
-          </a:p>
-        </p:txBody>
-      </p:sp>
-      <p:sp>
-        <p:nvSpPr>
-          <p:cNvPr name="TextBox 5" id="5"/>
-          <p:cNvSpPr txBox="true"/>
-          <p:nvPr/>
-        </p:nvSpPr>
-        <p:spPr>
-          <a:xfrm rot="0">
-            <a:off x="15264803" y="9812655"/>
-            <a:ext cx="2637975" cy="474345"/>
-          </a:xfrm>
-          <a:prstGeom prst="rect">
-            <a:avLst/>
-          </a:prstGeom>
-        </p:spPr>
-        <p:txBody>
-          <a:bodyPr anchor="t" rtlCol="false" tIns="0" lIns="0" bIns="0" rIns="0">
-            <a:spAutoFit/>
-          </a:bodyPr>
-          <a:lstStyle/>
-          <a:p>
-            <a:pPr algn="r">
-              <a:lnSpc>
-                <a:spcPts val="3779"/>
-              </a:lnSpc>
-              <a:spcBef>
-                <a:spcPct val="0"/>
-              </a:spcBef>
-            </a:pPr>
-            <a:r>
-              <a:rPr lang="en-US" sz="2700" spc="-135">
-                <a:solidFill>
-                  <a:srgbClr val="FFFFFF"/>
-                </a:solidFill>
-                <a:latin typeface="TDTD갬성명조"/>
-                <a:ea typeface="TDTD갬성명조"/>
-                <a:cs typeface="TDTD갬성명조"/>
-                <a:sym typeface="TDTD갬성명조"/>
-              </a:rPr>
-              <a:t>ⓒ 2026. Sunday Play</a:t>
-            </a:r>
-          </a:p>
-        </p:txBody>
-      </p:sp>
     </p:spTree>
   </p:cSld>
   <p:clrMapOvr>
@@ -6771,8 +6683,8 @@
         </p:nvSpPr>
         <p:spPr>
           <a:xfrm rot="0">
-            <a:off x="2717556" y="3895725"/>
-            <a:ext cx="12852888" cy="2200275"/>
+            <a:off x="2717556" y="7800975"/>
+            <a:ext cx="12852888" cy="1390650"/>
           </a:xfrm>
           <a:prstGeom prst="rect">
             <a:avLst/>
@@ -6786,20 +6698,61 @@
           <a:p>
             <a:pPr algn="ctr">
               <a:lnSpc>
-                <a:spcPts val="15000"/>
+                <a:spcPts val="10920"/>
               </a:lnSpc>
             </a:pPr>
             <a:r>
-              <a:rPr lang="en-US" sz="12500">
+              <a:rPr lang="en-US" sz="9100">
+                <a:solidFill>
+                  <a:srgbClr val="7D8AAB"/>
+                </a:solidFill>
+                <a:latin typeface="무궁화 고딕"/>
+                <a:ea typeface="무궁화 고딕"/>
+                <a:cs typeface="무궁화 고딕"/>
+                <a:sym typeface="무궁화 고딕"/>
+              </a:rPr>
+              <a:t>Hint. 사람이 타고 있어요</a:t>
+            </a:r>
+          </a:p>
+        </p:txBody>
+      </p:sp>
+      <p:sp>
+        <p:nvSpPr>
+          <p:cNvPr name="TextBox 5" id="5"/>
+          <p:cNvSpPr txBox="true"/>
+          <p:nvPr/>
+        </p:nvSpPr>
+        <p:spPr>
+          <a:xfrm rot="0">
+            <a:off x="2196188" y="3724275"/>
+            <a:ext cx="13895624" cy="2828925"/>
+          </a:xfrm>
+          <a:prstGeom prst="rect">
+            <a:avLst/>
+          </a:prstGeom>
+        </p:spPr>
+        <p:txBody>
+          <a:bodyPr anchor="t" rtlCol="false" tIns="0" lIns="0" bIns="0" rIns="0">
+            <a:spAutoFit/>
+          </a:bodyPr>
+          <a:lstStyle/>
+          <a:p>
+            <a:pPr algn="ctr">
+              <a:lnSpc>
+                <a:spcPts val="11160"/>
+              </a:lnSpc>
+            </a:pPr>
+            <a:r>
+              <a:rPr lang="en-US" sz="9300">
                 <a:solidFill>
                   <a:srgbClr val="000000"/>
                 </a:solidFill>
-                <a:latin typeface="Jua"/>
-                <a:ea typeface="Jua"/>
-                <a:cs typeface="Jua"/>
-                <a:sym typeface="Jua"/>
+                <a:latin typeface="무궁화 고딕"/>
+                <a:ea typeface="무궁화 고딕"/>
+                <a:cs typeface="무궁화 고딕"/>
+                <a:sym typeface="무궁화 고딕"/>
               </a:rPr>
-              <a:t>비행기</a:t>
+              <a:t>큰 새가 하늘에서 안 움직이고 가만히 있어요</a:t>
             </a:r>
           </a:p>
         </p:txBody>
@@ -6894,8 +6847,8 @@
         </p:nvSpPr>
         <p:spPr>
           <a:xfrm rot="0">
-            <a:off x="2717556" y="3495675"/>
-            <a:ext cx="12852888" cy="3076575"/>
+            <a:off x="2717556" y="4181475"/>
+            <a:ext cx="12852888" cy="1914525"/>
           </a:xfrm>
           <a:prstGeom prst="rect">
             <a:avLst/>
@@ -6909,20 +6862,20 @@
           <a:p>
             <a:pPr algn="ctr">
               <a:lnSpc>
-                <a:spcPts val="11280"/>
+                <a:spcPts val="15000"/>
               </a:lnSpc>
             </a:pPr>
             <a:r>
-              <a:rPr lang="en-US" sz="9400">
+              <a:rPr lang="en-US" sz="12500">
                 <a:solidFill>
                   <a:srgbClr val="000000"/>
                 </a:solidFill>
-                <a:latin typeface="Jua"/>
-                <a:ea typeface="Jua"/>
-                <a:cs typeface="Jua"/>
-                <a:sym typeface="Jua"/>
+                <a:latin typeface="무궁화 고딕"/>
+                <a:ea typeface="무궁화 고딕"/>
+                <a:cs typeface="무궁화 고딕"/>
+                <a:sym typeface="무궁화 고딕"/>
               </a:rPr>
-              <a:t>밤마다 엄마가 하얀 막대기로 입 안을 문질러요</a:t>
+              <a:t>비행기</a:t>
             </a:r>
           </a:p>
         </p:txBody>
@@ -7017,8 +6970,8 @@
         </p:nvSpPr>
         <p:spPr>
           <a:xfrm rot="0">
-            <a:off x="2717556" y="7505700"/>
-            <a:ext cx="12852888" cy="1752600"/>
+            <a:off x="2717556" y="3810000"/>
+            <a:ext cx="12852888" cy="2657475"/>
           </a:xfrm>
           <a:prstGeom prst="rect">
             <a:avLst/>
@@ -7032,59 +6985,18 @@
           <a:p>
             <a:pPr algn="ctr">
               <a:lnSpc>
-                <a:spcPts val="11999"/>
+                <a:spcPts val="10441"/>
               </a:lnSpc>
             </a:pPr>
             <a:r>
-              <a:rPr lang="en-US" sz="9999">
-                <a:solidFill>
-                  <a:srgbClr val="7D8AAB"/>
-                </a:solidFill>
-                <a:latin typeface="Jua"/>
-                <a:ea typeface="Jua"/>
-                <a:cs typeface="Jua"/>
-                <a:sym typeface="Jua"/>
-              </a:rPr>
-              <a:t>Hint. 안 하면 혼나요</a:t>
-            </a:r>
-          </a:p>
-        </p:txBody>
-      </p:sp>
-      <p:sp>
-        <p:nvSpPr>
-          <p:cNvPr name="TextBox 5" id="5"/>
-          <p:cNvSpPr txBox="true"/>
-          <p:nvPr/>
-        </p:nvSpPr>
-        <p:spPr>
-          <a:xfrm rot="0">
-            <a:off x="2717556" y="3495675"/>
-            <a:ext cx="12852888" cy="3076575"/>
-          </a:xfrm>
-          <a:prstGeom prst="rect">
-            <a:avLst/>
-          </a:prstGeom>
-        </p:spPr>
-        <p:txBody>
-          <a:bodyPr anchor="t" rtlCol="false" tIns="0" lIns="0" bIns="0" rIns="0">
-            <a:spAutoFit/>
-          </a:bodyPr>
-          <a:lstStyle/>
-          <a:p>
-            <a:pPr algn="ctr">
-              <a:lnSpc>
-                <a:spcPts val="11280"/>
-              </a:lnSpc>
-            </a:pPr>
-            <a:r>
-              <a:rPr lang="en-US" sz="9400">
+              <a:rPr lang="en-US" sz="8700">
                 <a:solidFill>
                   <a:srgbClr val="000000"/>
                 </a:solidFill>
-                <a:latin typeface="Jua"/>
-                <a:ea typeface="Jua"/>
-                <a:cs typeface="Jua"/>
-                <a:sym typeface="Jua"/>
+                <a:latin typeface="무궁화 고딕"/>
+                <a:ea typeface="무궁화 고딕"/>
+                <a:cs typeface="무궁화 고딕"/>
+                <a:sym typeface="무궁화 고딕"/>
               </a:rPr>
               <a:t>밤마다 엄마가 하얀 막대기로 입 안을 문질러요</a:t>
             </a:r>
@@ -7181,8 +7093,8 @@
         </p:nvSpPr>
         <p:spPr>
           <a:xfrm rot="0">
-            <a:off x="2717556" y="3895725"/>
-            <a:ext cx="12852888" cy="2200275"/>
+            <a:off x="2717556" y="7791450"/>
+            <a:ext cx="12852888" cy="1409700"/>
           </a:xfrm>
           <a:prstGeom prst="rect">
             <a:avLst/>
@@ -7196,20 +7108,61 @@
           <a:p>
             <a:pPr algn="ctr">
               <a:lnSpc>
-                <a:spcPts val="15000"/>
+                <a:spcPts val="11040"/>
               </a:lnSpc>
             </a:pPr>
             <a:r>
-              <a:rPr lang="en-US" sz="12500">
+              <a:rPr lang="en-US" sz="9200">
+                <a:solidFill>
+                  <a:srgbClr val="7D8AAB"/>
+                </a:solidFill>
+                <a:latin typeface="무궁화 고딕"/>
+                <a:ea typeface="무궁화 고딕"/>
+                <a:cs typeface="무궁화 고딕"/>
+                <a:sym typeface="무궁화 고딕"/>
+              </a:rPr>
+              <a:t>Hint. 안 하면 혼나요</a:t>
+            </a:r>
+          </a:p>
+        </p:txBody>
+      </p:sp>
+      <p:sp>
+        <p:nvSpPr>
+          <p:cNvPr name="TextBox 5" id="5"/>
+          <p:cNvSpPr txBox="true"/>
+          <p:nvPr/>
+        </p:nvSpPr>
+        <p:spPr>
+          <a:xfrm rot="0">
+            <a:off x="2717556" y="3810000"/>
+            <a:ext cx="12852888" cy="2657475"/>
+          </a:xfrm>
+          <a:prstGeom prst="rect">
+            <a:avLst/>
+          </a:prstGeom>
+        </p:spPr>
+        <p:txBody>
+          <a:bodyPr anchor="t" rtlCol="false" tIns="0" lIns="0" bIns="0" rIns="0">
+            <a:spAutoFit/>
+          </a:bodyPr>
+          <a:lstStyle/>
+          <a:p>
+            <a:pPr algn="ctr">
+              <a:lnSpc>
+                <a:spcPts val="10441"/>
+              </a:lnSpc>
+            </a:pPr>
+            <a:r>
+              <a:rPr lang="en-US" sz="8700">
                 <a:solidFill>
                   <a:srgbClr val="000000"/>
                 </a:solidFill>
-                <a:latin typeface="Jua"/>
-                <a:ea typeface="Jua"/>
-                <a:cs typeface="Jua"/>
-                <a:sym typeface="Jua"/>
+                <a:latin typeface="무궁화 고딕"/>
+                <a:ea typeface="무궁화 고딕"/>
+                <a:cs typeface="무궁화 고딕"/>
+                <a:sym typeface="무궁화 고딕"/>
               </a:rPr>
-              <a:t>양치질</a:t>
+              <a:t>밤마다 엄마가 하얀 막대기로 입 안을 문질러요</a:t>
             </a:r>
           </a:p>
         </p:txBody>
@@ -7304,8 +7257,8 @@
         </p:nvSpPr>
         <p:spPr>
           <a:xfrm rot="0">
-            <a:off x="2717556" y="3171825"/>
-            <a:ext cx="12852888" cy="3676650"/>
+            <a:off x="2717556" y="4181475"/>
+            <a:ext cx="12852888" cy="1914525"/>
           </a:xfrm>
           <a:prstGeom prst="rect">
             <a:avLst/>
@@ -7319,20 +7272,20 @@
           <a:p>
             <a:pPr algn="ctr">
               <a:lnSpc>
-                <a:spcPts val="13440"/>
+                <a:spcPts val="15000"/>
               </a:lnSpc>
             </a:pPr>
             <a:r>
-              <a:rPr lang="en-US" sz="11200">
+              <a:rPr lang="en-US" sz="12500">
                 <a:solidFill>
                   <a:srgbClr val="000000"/>
                 </a:solidFill>
-                <a:latin typeface="Jua"/>
-                <a:ea typeface="Jua"/>
-                <a:cs typeface="Jua"/>
-                <a:sym typeface="Jua"/>
+                <a:latin typeface="무궁화 고딕"/>
+                <a:ea typeface="무궁화 고딕"/>
+                <a:cs typeface="무궁화 고딕"/>
+                <a:sym typeface="무궁화 고딕"/>
               </a:rPr>
-              <a:t>아빠가 네모난 가방 들고 아침마다 사라져요</a:t>
+              <a:t>양치질</a:t>
             </a:r>
           </a:p>
         </p:txBody>
@@ -7427,8 +7380,8 @@
         </p:nvSpPr>
         <p:spPr>
           <a:xfrm rot="0">
-            <a:off x="2717556" y="7505700"/>
-            <a:ext cx="12852888" cy="1752600"/>
+            <a:off x="2717556" y="3552825"/>
+            <a:ext cx="12852888" cy="3171825"/>
           </a:xfrm>
           <a:prstGeom prst="rect">
             <a:avLst/>
@@ -7442,59 +7395,18 @@
           <a:p>
             <a:pPr algn="ctr">
               <a:lnSpc>
-                <a:spcPts val="11999"/>
+                <a:spcPts val="12480"/>
               </a:lnSpc>
             </a:pPr>
             <a:r>
-              <a:rPr lang="en-US" sz="9999">
-                <a:solidFill>
-                  <a:srgbClr val="7D8AAB"/>
-                </a:solidFill>
-                <a:latin typeface="Jua"/>
-                <a:ea typeface="Jua"/>
-                <a:cs typeface="Jua"/>
-                <a:sym typeface="Jua"/>
-              </a:rPr>
-              <a:t>Hint. 저녁에 돌아와요</a:t>
-            </a:r>
-          </a:p>
-        </p:txBody>
-      </p:sp>
-      <p:sp>
-        <p:nvSpPr>
-          <p:cNvPr name="TextBox 5" id="5"/>
-          <p:cNvSpPr txBox="true"/>
-          <p:nvPr/>
-        </p:nvSpPr>
-        <p:spPr>
-          <a:xfrm rot="0">
-            <a:off x="2717556" y="3171825"/>
-            <a:ext cx="12852888" cy="3676650"/>
-          </a:xfrm>
-          <a:prstGeom prst="rect">
-            <a:avLst/>
-          </a:prstGeom>
-        </p:spPr>
-        <p:txBody>
-          <a:bodyPr anchor="t" rtlCol="false" tIns="0" lIns="0" bIns="0" rIns="0">
-            <a:spAutoFit/>
-          </a:bodyPr>
-          <a:lstStyle/>
-          <a:p>
-            <a:pPr algn="ctr">
-              <a:lnSpc>
-                <a:spcPts val="13440"/>
-              </a:lnSpc>
-            </a:pPr>
-            <a:r>
-              <a:rPr lang="en-US" sz="11200">
+              <a:rPr lang="en-US" sz="10400">
                 <a:solidFill>
                   <a:srgbClr val="000000"/>
                 </a:solidFill>
-                <a:latin typeface="Jua"/>
-                <a:ea typeface="Jua"/>
-                <a:cs typeface="Jua"/>
-                <a:sym typeface="Jua"/>
+                <a:latin typeface="무궁화 고딕"/>
+                <a:ea typeface="무궁화 고딕"/>
+                <a:cs typeface="무궁화 고딕"/>
+                <a:sym typeface="무궁화 고딕"/>
               </a:rPr>
               <a:t>아빠가 네모난 가방 들고 아침마다 사라져요</a:t>
             </a:r>
@@ -7591,8 +7503,8 @@
         </p:nvSpPr>
         <p:spPr>
           <a:xfrm rot="0">
-            <a:off x="2717556" y="3895725"/>
-            <a:ext cx="12852888" cy="2200275"/>
+            <a:off x="2717556" y="7767637"/>
+            <a:ext cx="12852888" cy="1457325"/>
           </a:xfrm>
           <a:prstGeom prst="rect">
             <a:avLst/>
@@ -7606,20 +7518,61 @@
           <a:p>
             <a:pPr algn="ctr">
               <a:lnSpc>
-                <a:spcPts val="15000"/>
+                <a:spcPts val="11400"/>
               </a:lnSpc>
             </a:pPr>
             <a:r>
-              <a:rPr lang="en-US" sz="12500">
+              <a:rPr lang="en-US" sz="9500">
+                <a:solidFill>
+                  <a:srgbClr val="7D8AAB"/>
+                </a:solidFill>
+                <a:latin typeface="무궁화 고딕"/>
+                <a:ea typeface="무궁화 고딕"/>
+                <a:cs typeface="무궁화 고딕"/>
+                <a:sym typeface="무궁화 고딕"/>
+              </a:rPr>
+              <a:t>Hint. 저녁에 돌아와요</a:t>
+            </a:r>
+          </a:p>
+        </p:txBody>
+      </p:sp>
+      <p:sp>
+        <p:nvSpPr>
+          <p:cNvPr name="TextBox 5" id="5"/>
+          <p:cNvSpPr txBox="true"/>
+          <p:nvPr/>
+        </p:nvSpPr>
+        <p:spPr>
+          <a:xfrm rot="0">
+            <a:off x="2717556" y="3552825"/>
+            <a:ext cx="12852888" cy="3171825"/>
+          </a:xfrm>
+          <a:prstGeom prst="rect">
+            <a:avLst/>
+          </a:prstGeom>
+        </p:spPr>
+        <p:txBody>
+          <a:bodyPr anchor="t" rtlCol="false" tIns="0" lIns="0" bIns="0" rIns="0">
+            <a:spAutoFit/>
+          </a:bodyPr>
+          <a:lstStyle/>
+          <a:p>
+            <a:pPr algn="ctr">
+              <a:lnSpc>
+                <a:spcPts val="12480"/>
+              </a:lnSpc>
+            </a:pPr>
+            <a:r>
+              <a:rPr lang="en-US" sz="10400">
                 <a:solidFill>
                   <a:srgbClr val="000000"/>
                 </a:solidFill>
-                <a:latin typeface="Jua"/>
-                <a:ea typeface="Jua"/>
-                <a:cs typeface="Jua"/>
-                <a:sym typeface="Jua"/>
+                <a:latin typeface="무궁화 고딕"/>
+                <a:ea typeface="무궁화 고딕"/>
+                <a:cs typeface="무궁화 고딕"/>
+                <a:sym typeface="무궁화 고딕"/>
               </a:rPr>
-              <a:t>출근</a:t>
+              <a:t>아빠가 네모난 가방 들고 아침마다 사라져요</a:t>
             </a:r>
           </a:p>
         </p:txBody>
@@ -7714,8 +7667,8 @@
         </p:nvSpPr>
         <p:spPr>
           <a:xfrm rot="0">
-            <a:off x="2717556" y="3124200"/>
-            <a:ext cx="12852888" cy="3771900"/>
+            <a:off x="2717556" y="4181475"/>
+            <a:ext cx="12852888" cy="1914525"/>
           </a:xfrm>
           <a:prstGeom prst="rect">
             <a:avLst/>
@@ -7729,20 +7682,20 @@
           <a:p>
             <a:pPr algn="ctr">
               <a:lnSpc>
-                <a:spcPts val="13800"/>
+                <a:spcPts val="15000"/>
               </a:lnSpc>
             </a:pPr>
             <a:r>
-              <a:rPr lang="en-US" sz="11500">
+              <a:rPr lang="en-US" sz="12500">
                 <a:solidFill>
                   <a:srgbClr val="000000"/>
                 </a:solidFill>
-                <a:latin typeface="Jua"/>
-                <a:ea typeface="Jua"/>
-                <a:cs typeface="Jua"/>
-                <a:sym typeface="Jua"/>
+                <a:latin typeface="무궁화 고딕"/>
+                <a:ea typeface="무궁화 고딕"/>
+                <a:cs typeface="무궁화 고딕"/>
+                <a:sym typeface="무궁화 고딕"/>
               </a:rPr>
-              <a:t>아빠가 동그란 거 잡고 돌리면 집이 움직여요</a:t>
+              <a:t>출근</a:t>
             </a:r>
           </a:p>
         </p:txBody>
@@ -7837,49 +7790,8 @@
         </p:nvSpPr>
         <p:spPr>
           <a:xfrm rot="0">
-            <a:off x="2717556" y="7505700"/>
-            <a:ext cx="12852888" cy="1752600"/>
-          </a:xfrm>
-          <a:prstGeom prst="rect">
-            <a:avLst/>
-          </a:prstGeom>
-        </p:spPr>
-        <p:txBody>
-          <a:bodyPr anchor="t" rtlCol="false" tIns="0" lIns="0" bIns="0" rIns="0">
-            <a:spAutoFit/>
-          </a:bodyPr>
-          <a:lstStyle/>
-          <a:p>
-            <a:pPr algn="ctr">
-              <a:lnSpc>
-                <a:spcPts val="11999"/>
-              </a:lnSpc>
-            </a:pPr>
-            <a:r>
-              <a:rPr lang="en-US" sz="9999">
-                <a:solidFill>
-                  <a:srgbClr val="7D8AAB"/>
-                </a:solidFill>
-                <a:latin typeface="Jua"/>
-                <a:ea typeface="Jua"/>
-                <a:cs typeface="Jua"/>
-                <a:sym typeface="Jua"/>
-              </a:rPr>
-              <a:t>Hint. 바퀴가 달렸어요</a:t>
-            </a:r>
-          </a:p>
-        </p:txBody>
-      </p:sp>
-      <p:sp>
-        <p:nvSpPr>
-          <p:cNvPr name="TextBox 5" id="5"/>
-          <p:cNvSpPr txBox="true"/>
-          <p:nvPr/>
-        </p:nvSpPr>
-        <p:spPr>
-          <a:xfrm rot="0">
-            <a:off x="2717556" y="3124200"/>
-            <a:ext cx="12852888" cy="3771900"/>
+            <a:off x="2717556" y="3381375"/>
+            <a:ext cx="12852888" cy="3514725"/>
           </a:xfrm>
           <a:prstGeom prst="rect">
             <a:avLst/>
@@ -7901,10 +7813,10 @@
                 <a:solidFill>
                   <a:srgbClr val="000000"/>
                 </a:solidFill>
-                <a:latin typeface="Jua"/>
-                <a:ea typeface="Jua"/>
-                <a:cs typeface="Jua"/>
-                <a:sym typeface="Jua"/>
+                <a:latin typeface="무궁화 고딕"/>
+                <a:ea typeface="무궁화 고딕"/>
+                <a:cs typeface="무궁화 고딕"/>
+                <a:sym typeface="무궁화 고딕"/>
               </a:rPr>
               <a:t>아빠가 동그란 거 잡고 돌리면 집이 움직여요</a:t>
             </a:r>
@@ -8001,8 +7913,8 @@
         </p:nvSpPr>
         <p:spPr>
           <a:xfrm rot="0">
-            <a:off x="2717556" y="3895725"/>
-            <a:ext cx="12852888" cy="2200275"/>
+            <a:off x="2717556" y="7743825"/>
+            <a:ext cx="12852888" cy="1514475"/>
           </a:xfrm>
           <a:prstGeom prst="rect">
             <a:avLst/>
@@ -8016,20 +7928,61 @@
           <a:p>
             <a:pPr algn="ctr">
               <a:lnSpc>
-                <a:spcPts val="15000"/>
+                <a:spcPts val="11999"/>
               </a:lnSpc>
             </a:pPr>
             <a:r>
-              <a:rPr lang="en-US" sz="12500">
+              <a:rPr lang="en-US" sz="9999">
+                <a:solidFill>
+                  <a:srgbClr val="7D8AAB"/>
+                </a:solidFill>
+                <a:latin typeface="무궁화 고딕"/>
+                <a:ea typeface="무궁화 고딕"/>
+                <a:cs typeface="무궁화 고딕"/>
+                <a:sym typeface="무궁화 고딕"/>
+              </a:rPr>
+              <a:t>Hint. 바퀴가 달렸어요</a:t>
+            </a:r>
+          </a:p>
+        </p:txBody>
+      </p:sp>
+      <p:sp>
+        <p:nvSpPr>
+          <p:cNvPr name="TextBox 5" id="5"/>
+          <p:cNvSpPr txBox="true"/>
+          <p:nvPr/>
+        </p:nvSpPr>
+        <p:spPr>
+          <a:xfrm rot="0">
+            <a:off x="2717556" y="3381375"/>
+            <a:ext cx="12852888" cy="3514725"/>
+          </a:xfrm>
+          <a:prstGeom prst="rect">
+            <a:avLst/>
+          </a:prstGeom>
+        </p:spPr>
+        <p:txBody>
+          <a:bodyPr anchor="t" rtlCol="false" tIns="0" lIns="0" bIns="0" rIns="0">
+            <a:spAutoFit/>
+          </a:bodyPr>
+          <a:lstStyle/>
+          <a:p>
+            <a:pPr algn="ctr">
+              <a:lnSpc>
+                <a:spcPts val="13800"/>
+              </a:lnSpc>
+            </a:pPr>
+            <a:r>
+              <a:rPr lang="en-US" sz="11500">
                 <a:solidFill>
                   <a:srgbClr val="000000"/>
                 </a:solidFill>
-                <a:latin typeface="Jua"/>
-                <a:ea typeface="Jua"/>
-                <a:cs typeface="Jua"/>
-                <a:sym typeface="Jua"/>
+                <a:latin typeface="무궁화 고딕"/>
+                <a:ea typeface="무궁화 고딕"/>
+                <a:cs typeface="무궁화 고딕"/>
+                <a:sym typeface="무궁화 고딕"/>
               </a:rPr>
-              <a:t>자동차</a:t>
+              <a:t>아빠가 동그란 거 잡고 돌리면 집이 움직여요</a:t>
             </a:r>
           </a:p>
         </p:txBody>
@@ -8048,7 +8001,7 @@
     <p:bg>
       <p:bgPr>
         <a:solidFill>
-          <a:srgbClr val="FFFAEF"/>
+          <a:srgbClr val="7D8AAB"/>
         </a:solidFill>
       </p:bgPr>
     </p:bg>
@@ -8076,15 +8029,15 @@
         </p:nvPicPr>
         <p:blipFill>
           <a:blip r:embed="rId2"/>
-          <a:srcRect l="0" t="0" r="0" b="0"/>
+          <a:srcRect l="64771" t="21970" r="0" b="0"/>
           <a:stretch>
             <a:fillRect/>
           </a:stretch>
         </p:blipFill>
         <p:spPr>
-          <a:xfrm flipH="false" flipV="false" rot="0">
-            <a:off x="13655377" y="6809666"/>
-            <a:ext cx="6229999" cy="6954669"/>
+          <a:xfrm flipH="false" flipV="false" rot="5400000">
+            <a:off x="2310738" y="4172522"/>
+            <a:ext cx="3803740" cy="8425216"/>
           </a:xfrm>
           <a:prstGeom prst="rect">
             <a:avLst/>
@@ -8107,9 +8060,9 @@
           </a:stretch>
         </p:blipFill>
         <p:spPr>
-          <a:xfrm flipH="false" flipV="false" rot="0">
-            <a:off x="0" y="0"/>
-            <a:ext cx="6925457" cy="4700654"/>
+          <a:xfrm flipH="false" flipV="false" rot="-7094170">
+            <a:off x="14148180" y="-2590072"/>
+            <a:ext cx="7036829" cy="7237544"/>
           </a:xfrm>
           <a:prstGeom prst="rect">
             <a:avLst/>
@@ -8124,8 +8077,8 @@
         </p:nvSpPr>
         <p:spPr>
           <a:xfrm rot="0">
-            <a:off x="2717556" y="2943225"/>
-            <a:ext cx="12852888" cy="4105275"/>
+            <a:off x="1028700" y="4178617"/>
+            <a:ext cx="15555091" cy="1914525"/>
           </a:xfrm>
           <a:prstGeom prst="rect">
             <a:avLst/>
@@ -8145,33 +8098,58 @@
             <a:r>
               <a:rPr lang="en-US" sz="12500">
                 <a:solidFill>
-                  <a:srgbClr val="000000"/>
+                  <a:srgbClr val="FFFAEF"/>
                 </a:solidFill>
-                <a:latin typeface="Jua"/>
-                <a:ea typeface="Jua"/>
-                <a:cs typeface="Jua"/>
-                <a:sym typeface="Jua"/>
+                <a:latin typeface="무궁화 고딕"/>
+                <a:ea typeface="무궁화 고딕"/>
+                <a:cs typeface="무궁화 고딕"/>
+                <a:sym typeface="무궁화 고딕"/>
               </a:rPr>
-              <a:t>엄마가 일어나면</a:t>
-            </a:r>
-          </a:p>
-          <a:p>
-            <a:pPr algn="ctr">
+              <a:t>눈높이 퀴즈</a:t>
+            </a:r>
+          </a:p>
+        </p:txBody>
+      </p:sp>
+      <p:sp>
+        <p:nvSpPr>
+          <p:cNvPr name="TextBox 5" id="5"/>
+          <p:cNvSpPr txBox="true"/>
+          <p:nvPr/>
+        </p:nvSpPr>
+        <p:spPr>
+          <a:xfrm rot="0">
+            <a:off x="14522856" y="9822180"/>
+            <a:ext cx="3379923" cy="464820"/>
+          </a:xfrm>
+          <a:prstGeom prst="rect">
+            <a:avLst/>
+          </a:prstGeom>
+        </p:spPr>
+        <p:txBody>
+          <a:bodyPr anchor="t" rtlCol="false" tIns="0" lIns="0" bIns="0" rIns="0">
+            <a:spAutoFit/>
+          </a:bodyPr>
+          <a:lstStyle/>
+          <a:p>
+            <a:pPr algn="r">
               <a:lnSpc>
-                <a:spcPts val="15000"/>
+                <a:spcPts val="3779"/>
               </a:lnSpc>
+              <a:spcBef>
+                <a:spcPct val="0"/>
+              </a:spcBef>
             </a:pPr>
             <a:r>
-              <a:rPr lang="en-US" sz="12500">
+              <a:rPr lang="en-US" sz="2700" spc="-135">
                 <a:solidFill>
-                  <a:srgbClr val="000000"/>
+                  <a:srgbClr val="FFFFFF"/>
                 </a:solidFill>
-                <a:latin typeface="Jua"/>
-                <a:ea typeface="Jua"/>
-                <a:cs typeface="Jua"/>
-                <a:sym typeface="Jua"/>
+                <a:latin typeface="무궁화 고딕"/>
+                <a:ea typeface="무궁화 고딕"/>
+                <a:cs typeface="무궁화 고딕"/>
+                <a:sym typeface="무궁화 고딕"/>
               </a:rPr>
-              <a:t>아빠가 책을 봐요</a:t>
+              <a:t>ⓒ 2026. Sunday Play</a:t>
             </a:r>
           </a:p>
         </p:txBody>
@@ -8266,8 +8244,8 @@
         </p:nvSpPr>
         <p:spPr>
           <a:xfrm rot="0">
-            <a:off x="2717556" y="3124200"/>
-            <a:ext cx="12852888" cy="3771900"/>
+            <a:off x="2717556" y="4181475"/>
+            <a:ext cx="12852888" cy="1914525"/>
           </a:xfrm>
           <a:prstGeom prst="rect">
             <a:avLst/>
@@ -8281,20 +8259,20 @@
           <a:p>
             <a:pPr algn="ctr">
               <a:lnSpc>
-                <a:spcPts val="13800"/>
+                <a:spcPts val="15000"/>
               </a:lnSpc>
             </a:pPr>
             <a:r>
-              <a:rPr lang="en-US" sz="11500">
+              <a:rPr lang="en-US" sz="12500">
                 <a:solidFill>
                   <a:srgbClr val="000000"/>
                 </a:solidFill>
-                <a:latin typeface="Jua"/>
-                <a:ea typeface="Jua"/>
-                <a:cs typeface="Jua"/>
-                <a:sym typeface="Jua"/>
+                <a:latin typeface="무궁화 고딕"/>
+                <a:ea typeface="무궁화 고딕"/>
+                <a:cs typeface="무궁화 고딕"/>
+                <a:sym typeface="무궁화 고딕"/>
               </a:rPr>
-              <a:t>네모난 종이인데 넣으면 어른들이 좋아해요</a:t>
+              <a:t>자동차</a:t>
             </a:r>
           </a:p>
         </p:txBody>
@@ -8389,8 +8367,8 @@
         </p:nvSpPr>
         <p:spPr>
           <a:xfrm rot="0">
-            <a:off x="2717556" y="7505700"/>
-            <a:ext cx="12852888" cy="1752600"/>
+            <a:off x="2717556" y="3505200"/>
+            <a:ext cx="12852888" cy="3267075"/>
           </a:xfrm>
           <a:prstGeom prst="rect">
             <a:avLst/>
@@ -8404,59 +8382,18 @@
           <a:p>
             <a:pPr algn="ctr">
               <a:lnSpc>
-                <a:spcPts val="11999"/>
+                <a:spcPts val="12840"/>
               </a:lnSpc>
             </a:pPr>
             <a:r>
-              <a:rPr lang="en-US" sz="9999">
-                <a:solidFill>
-                  <a:srgbClr val="7D8AAB"/>
-                </a:solidFill>
-                <a:latin typeface="Jua"/>
-                <a:ea typeface="Jua"/>
-                <a:cs typeface="Jua"/>
-                <a:sym typeface="Jua"/>
-              </a:rPr>
-              <a:t>Hint. 지갑에 있어요</a:t>
-            </a:r>
-          </a:p>
-        </p:txBody>
-      </p:sp>
-      <p:sp>
-        <p:nvSpPr>
-          <p:cNvPr name="TextBox 5" id="5"/>
-          <p:cNvSpPr txBox="true"/>
-          <p:nvPr/>
-        </p:nvSpPr>
-        <p:spPr>
-          <a:xfrm rot="0">
-            <a:off x="2717556" y="3124200"/>
-            <a:ext cx="12852888" cy="3771900"/>
-          </a:xfrm>
-          <a:prstGeom prst="rect">
-            <a:avLst/>
-          </a:prstGeom>
-        </p:spPr>
-        <p:txBody>
-          <a:bodyPr anchor="t" rtlCol="false" tIns="0" lIns="0" bIns="0" rIns="0">
-            <a:spAutoFit/>
-          </a:bodyPr>
-          <a:lstStyle/>
-          <a:p>
-            <a:pPr algn="ctr">
-              <a:lnSpc>
-                <a:spcPts val="13800"/>
-              </a:lnSpc>
-            </a:pPr>
-            <a:r>
-              <a:rPr lang="en-US" sz="11500">
+              <a:rPr lang="en-US" sz="10700">
                 <a:solidFill>
                   <a:srgbClr val="000000"/>
                 </a:solidFill>
-                <a:latin typeface="Jua"/>
-                <a:ea typeface="Jua"/>
-                <a:cs typeface="Jua"/>
-                <a:sym typeface="Jua"/>
+                <a:latin typeface="무궁화 고딕"/>
+                <a:ea typeface="무궁화 고딕"/>
+                <a:cs typeface="무궁화 고딕"/>
+                <a:sym typeface="무궁화 고딕"/>
               </a:rPr>
               <a:t>네모난 종이인데 넣으면 어른들이 좋아해요</a:t>
             </a:r>
@@ -8553,8 +8490,8 @@
         </p:nvSpPr>
         <p:spPr>
           <a:xfrm rot="0">
-            <a:off x="2717556" y="3895725"/>
-            <a:ext cx="12852888" cy="2200275"/>
+            <a:off x="2717556" y="7743825"/>
+            <a:ext cx="12852888" cy="1514475"/>
           </a:xfrm>
           <a:prstGeom prst="rect">
             <a:avLst/>
@@ -8568,20 +8505,61 @@
           <a:p>
             <a:pPr algn="ctr">
               <a:lnSpc>
-                <a:spcPts val="15000"/>
+                <a:spcPts val="11999"/>
               </a:lnSpc>
             </a:pPr>
             <a:r>
-              <a:rPr lang="en-US" sz="12500">
+              <a:rPr lang="en-US" sz="9999">
+                <a:solidFill>
+                  <a:srgbClr val="7D8AAB"/>
+                </a:solidFill>
+                <a:latin typeface="무궁화 고딕"/>
+                <a:ea typeface="무궁화 고딕"/>
+                <a:cs typeface="무궁화 고딕"/>
+                <a:sym typeface="무궁화 고딕"/>
+              </a:rPr>
+              <a:t>Hint. 지갑에 있어요</a:t>
+            </a:r>
+          </a:p>
+        </p:txBody>
+      </p:sp>
+      <p:sp>
+        <p:nvSpPr>
+          <p:cNvPr name="TextBox 5" id="5"/>
+          <p:cNvSpPr txBox="true"/>
+          <p:nvPr/>
+        </p:nvSpPr>
+        <p:spPr>
+          <a:xfrm rot="0">
+            <a:off x="2717556" y="3505200"/>
+            <a:ext cx="12852888" cy="3267075"/>
+          </a:xfrm>
+          <a:prstGeom prst="rect">
+            <a:avLst/>
+          </a:prstGeom>
+        </p:spPr>
+        <p:txBody>
+          <a:bodyPr anchor="t" rtlCol="false" tIns="0" lIns="0" bIns="0" rIns="0">
+            <a:spAutoFit/>
+          </a:bodyPr>
+          <a:lstStyle/>
+          <a:p>
+            <a:pPr algn="ctr">
+              <a:lnSpc>
+                <a:spcPts val="12840"/>
+              </a:lnSpc>
+            </a:pPr>
+            <a:r>
+              <a:rPr lang="en-US" sz="10700">
                 <a:solidFill>
                   <a:srgbClr val="000000"/>
                 </a:solidFill>
-                <a:latin typeface="Jua"/>
-                <a:ea typeface="Jua"/>
-                <a:cs typeface="Jua"/>
-                <a:sym typeface="Jua"/>
+                <a:latin typeface="무궁화 고딕"/>
+                <a:ea typeface="무궁화 고딕"/>
+                <a:cs typeface="무궁화 고딕"/>
+                <a:sym typeface="무궁화 고딕"/>
               </a:rPr>
-              <a:t>돈(지폐)</a:t>
+              <a:t>네모난 종이인데 넣으면 어른들이 좋아해요</a:t>
             </a:r>
           </a:p>
         </p:txBody>
@@ -8676,8 +8654,8 @@
         </p:nvSpPr>
         <p:spPr>
           <a:xfrm rot="0">
-            <a:off x="2717556" y="2943225"/>
-            <a:ext cx="12852888" cy="4105275"/>
+            <a:off x="2717556" y="4181475"/>
+            <a:ext cx="12852888" cy="1914525"/>
           </a:xfrm>
           <a:prstGeom prst="rect">
             <a:avLst/>
@@ -8699,31 +8677,12 @@
                 <a:solidFill>
                   <a:srgbClr val="000000"/>
                 </a:solidFill>
-                <a:latin typeface="Jua"/>
-                <a:ea typeface="Jua"/>
-                <a:cs typeface="Jua"/>
-                <a:sym typeface="Jua"/>
+                <a:latin typeface="무궁화 고딕"/>
+                <a:ea typeface="무궁화 고딕"/>
+                <a:cs typeface="무궁화 고딕"/>
+                <a:sym typeface="무궁화 고딕"/>
               </a:rPr>
-              <a:t>작은 방에 들어가면</a:t>
-            </a:r>
-          </a:p>
-          <a:p>
-            <a:pPr algn="ctr">
-              <a:lnSpc>
-                <a:spcPts val="15000"/>
-              </a:lnSpc>
-            </a:pPr>
-            <a:r>
-              <a:rPr lang="en-US" sz="12500">
-                <a:solidFill>
-                  <a:srgbClr val="000000"/>
-                </a:solidFill>
-                <a:latin typeface="Jua"/>
-                <a:ea typeface="Jua"/>
-                <a:cs typeface="Jua"/>
-                <a:sym typeface="Jua"/>
-              </a:rPr>
-              <a:t>속이 울렁거려요</a:t>
+              <a:t>돈(지폐)</a:t>
             </a:r>
           </a:p>
         </p:txBody>
@@ -8818,49 +8777,8 @@
         </p:nvSpPr>
         <p:spPr>
           <a:xfrm rot="0">
-            <a:off x="2717556" y="7505700"/>
-            <a:ext cx="12852888" cy="1752600"/>
-          </a:xfrm>
-          <a:prstGeom prst="rect">
-            <a:avLst/>
-          </a:prstGeom>
-        </p:spPr>
-        <p:txBody>
-          <a:bodyPr anchor="t" rtlCol="false" tIns="0" lIns="0" bIns="0" rIns="0">
-            <a:spAutoFit/>
-          </a:bodyPr>
-          <a:lstStyle/>
-          <a:p>
-            <a:pPr algn="ctr">
-              <a:lnSpc>
-                <a:spcPts val="11999"/>
-              </a:lnSpc>
-            </a:pPr>
-            <a:r>
-              <a:rPr lang="en-US" sz="9999">
-                <a:solidFill>
-                  <a:srgbClr val="7D8AAB"/>
-                </a:solidFill>
-                <a:latin typeface="Jua"/>
-                <a:ea typeface="Jua"/>
-                <a:cs typeface="Jua"/>
-                <a:sym typeface="Jua"/>
-              </a:rPr>
-              <a:t>Hint. 숫자가 있어요</a:t>
-            </a:r>
-          </a:p>
-        </p:txBody>
-      </p:sp>
-      <p:sp>
-        <p:nvSpPr>
-          <p:cNvPr name="TextBox 5" id="5"/>
-          <p:cNvSpPr txBox="true"/>
-          <p:nvPr/>
-        </p:nvSpPr>
-        <p:spPr>
-          <a:xfrm rot="0">
-            <a:off x="2717556" y="2943225"/>
-            <a:ext cx="12852888" cy="4105275"/>
+            <a:off x="2717556" y="3228975"/>
+            <a:ext cx="12852888" cy="3819525"/>
           </a:xfrm>
           <a:prstGeom prst="rect">
             <a:avLst/>
@@ -8882,10 +8800,10 @@
                 <a:solidFill>
                   <a:srgbClr val="000000"/>
                 </a:solidFill>
-                <a:latin typeface="Jua"/>
-                <a:ea typeface="Jua"/>
-                <a:cs typeface="Jua"/>
-                <a:sym typeface="Jua"/>
+                <a:latin typeface="무궁화 고딕"/>
+                <a:ea typeface="무궁화 고딕"/>
+                <a:cs typeface="무궁화 고딕"/>
+                <a:sym typeface="무궁화 고딕"/>
               </a:rPr>
               <a:t>작은 방에 들어가면</a:t>
             </a:r>
@@ -8901,10 +8819,10 @@
                 <a:solidFill>
                   <a:srgbClr val="000000"/>
                 </a:solidFill>
-                <a:latin typeface="Jua"/>
-                <a:ea typeface="Jua"/>
-                <a:cs typeface="Jua"/>
-                <a:sym typeface="Jua"/>
+                <a:latin typeface="무궁화 고딕"/>
+                <a:ea typeface="무궁화 고딕"/>
+                <a:cs typeface="무궁화 고딕"/>
+                <a:sym typeface="무궁화 고딕"/>
               </a:rPr>
               <a:t>속이 울렁거려요</a:t>
             </a:r>
@@ -9001,8 +8919,49 @@
         </p:nvSpPr>
         <p:spPr>
           <a:xfrm rot="0">
-            <a:off x="2717556" y="3895725"/>
-            <a:ext cx="12852888" cy="2200275"/>
+            <a:off x="2717556" y="7743825"/>
+            <a:ext cx="12852888" cy="1514475"/>
+          </a:xfrm>
+          <a:prstGeom prst="rect">
+            <a:avLst/>
+          </a:prstGeom>
+        </p:spPr>
+        <p:txBody>
+          <a:bodyPr anchor="t" rtlCol="false" tIns="0" lIns="0" bIns="0" rIns="0">
+            <a:spAutoFit/>
+          </a:bodyPr>
+          <a:lstStyle/>
+          <a:p>
+            <a:pPr algn="ctr">
+              <a:lnSpc>
+                <a:spcPts val="11999"/>
+              </a:lnSpc>
+            </a:pPr>
+            <a:r>
+              <a:rPr lang="en-US" sz="9999">
+                <a:solidFill>
+                  <a:srgbClr val="7D8AAB"/>
+                </a:solidFill>
+                <a:latin typeface="무궁화 고딕"/>
+                <a:ea typeface="무궁화 고딕"/>
+                <a:cs typeface="무궁화 고딕"/>
+                <a:sym typeface="무궁화 고딕"/>
+              </a:rPr>
+              <a:t>Hint. 숫자가 있어요</a:t>
+            </a:r>
+          </a:p>
+        </p:txBody>
+      </p:sp>
+      <p:sp>
+        <p:nvSpPr>
+          <p:cNvPr name="TextBox 5" id="5"/>
+          <p:cNvSpPr txBox="true"/>
+          <p:nvPr/>
+        </p:nvSpPr>
+        <p:spPr>
+          <a:xfrm rot="0">
+            <a:off x="2717556" y="3228975"/>
+            <a:ext cx="12852888" cy="3819525"/>
           </a:xfrm>
           <a:prstGeom prst="rect">
             <a:avLst/>
@@ -9024,12 +8983,31 @@
                 <a:solidFill>
                   <a:srgbClr val="000000"/>
                 </a:solidFill>
-                <a:latin typeface="Jua"/>
-                <a:ea typeface="Jua"/>
-                <a:cs typeface="Jua"/>
-                <a:sym typeface="Jua"/>
+                <a:latin typeface="무궁화 고딕"/>
+                <a:ea typeface="무궁화 고딕"/>
+                <a:cs typeface="무궁화 고딕"/>
+                <a:sym typeface="무궁화 고딕"/>
               </a:rPr>
-              <a:t>엘리베이터</a:t>
+              <a:t>작은 방에 들어가면</a:t>
+            </a:r>
+          </a:p>
+          <a:p>
+            <a:pPr algn="ctr">
+              <a:lnSpc>
+                <a:spcPts val="15000"/>
+              </a:lnSpc>
+            </a:pPr>
+            <a:r>
+              <a:rPr lang="en-US" sz="12500">
+                <a:solidFill>
+                  <a:srgbClr val="000000"/>
+                </a:solidFill>
+                <a:latin typeface="무궁화 고딕"/>
+                <a:ea typeface="무궁화 고딕"/>
+                <a:cs typeface="무궁화 고딕"/>
+                <a:sym typeface="무궁화 고딕"/>
+              </a:rPr>
+              <a:t>속이 울렁거려요</a:t>
             </a:r>
           </a:p>
         </p:txBody>
@@ -9124,8 +9102,8 @@
         </p:nvSpPr>
         <p:spPr>
           <a:xfrm rot="0">
-            <a:off x="2717556" y="3371850"/>
-            <a:ext cx="12852888" cy="3295650"/>
+            <a:off x="2717556" y="4181475"/>
+            <a:ext cx="12852888" cy="1914525"/>
           </a:xfrm>
           <a:prstGeom prst="rect">
             <a:avLst/>
@@ -9139,20 +9117,20 @@
           <a:p>
             <a:pPr algn="ctr">
               <a:lnSpc>
-                <a:spcPts val="12000"/>
+                <a:spcPts val="15000"/>
               </a:lnSpc>
             </a:pPr>
             <a:r>
-              <a:rPr lang="en-US" sz="10000">
+              <a:rPr lang="en-US" sz="12500">
                 <a:solidFill>
                   <a:srgbClr val="000000"/>
                 </a:solidFill>
-                <a:latin typeface="Jua"/>
-                <a:ea typeface="Jua"/>
-                <a:cs typeface="Jua"/>
-                <a:sym typeface="Jua"/>
+                <a:latin typeface="무궁화 고딕"/>
+                <a:ea typeface="무궁화 고딕"/>
+                <a:cs typeface="무궁화 고딕"/>
+                <a:sym typeface="무궁화 고딕"/>
               </a:rPr>
-              <a:t>하얀 이불을 까만 입에 넣으면 빙글빙글 돌려서 뱉어요</a:t>
+              <a:t>엘리베이터</a:t>
             </a:r>
           </a:p>
         </p:txBody>
@@ -9247,8 +9225,8 @@
         </p:nvSpPr>
         <p:spPr>
           <a:xfrm rot="0">
-            <a:off x="2717556" y="7505700"/>
-            <a:ext cx="12852888" cy="1752600"/>
+            <a:off x="2717556" y="3733800"/>
+            <a:ext cx="12852888" cy="2809875"/>
           </a:xfrm>
           <a:prstGeom prst="rect">
             <a:avLst/>
@@ -9262,59 +9240,18 @@
           <a:p>
             <a:pPr algn="ctr">
               <a:lnSpc>
-                <a:spcPts val="11999"/>
+                <a:spcPts val="11041"/>
               </a:lnSpc>
             </a:pPr>
             <a:r>
-              <a:rPr lang="en-US" sz="9999">
-                <a:solidFill>
-                  <a:srgbClr val="7D8AAB"/>
-                </a:solidFill>
-                <a:latin typeface="Jua"/>
-                <a:ea typeface="Jua"/>
-                <a:cs typeface="Jua"/>
-                <a:sym typeface="Jua"/>
-              </a:rPr>
-              <a:t>Hint. 물도 같이 들어가요</a:t>
-            </a:r>
-          </a:p>
-        </p:txBody>
-      </p:sp>
-      <p:sp>
-        <p:nvSpPr>
-          <p:cNvPr name="TextBox 5" id="5"/>
-          <p:cNvSpPr txBox="true"/>
-          <p:nvPr/>
-        </p:nvSpPr>
-        <p:spPr>
-          <a:xfrm rot="0">
-            <a:off x="2717556" y="3371850"/>
-            <a:ext cx="12852888" cy="3295650"/>
-          </a:xfrm>
-          <a:prstGeom prst="rect">
-            <a:avLst/>
-          </a:prstGeom>
-        </p:spPr>
-        <p:txBody>
-          <a:bodyPr anchor="t" rtlCol="false" tIns="0" lIns="0" bIns="0" rIns="0">
-            <a:spAutoFit/>
-          </a:bodyPr>
-          <a:lstStyle/>
-          <a:p>
-            <a:pPr algn="ctr">
-              <a:lnSpc>
-                <a:spcPts val="12000"/>
-              </a:lnSpc>
-            </a:pPr>
-            <a:r>
-              <a:rPr lang="en-US" sz="10000">
+              <a:rPr lang="en-US" sz="9200">
                 <a:solidFill>
                   <a:srgbClr val="000000"/>
                 </a:solidFill>
-                <a:latin typeface="Jua"/>
-                <a:ea typeface="Jua"/>
-                <a:cs typeface="Jua"/>
-                <a:sym typeface="Jua"/>
+                <a:latin typeface="무궁화 고딕"/>
+                <a:ea typeface="무궁화 고딕"/>
+                <a:cs typeface="무궁화 고딕"/>
+                <a:sym typeface="무궁화 고딕"/>
               </a:rPr>
               <a:t>하얀 이불을 까만 입에 넣으면 빙글빙글 돌려서 뱉어요</a:t>
             </a:r>
@@ -9411,8 +9348,8 @@
         </p:nvSpPr>
         <p:spPr>
           <a:xfrm rot="0">
-            <a:off x="2717556" y="3895725"/>
-            <a:ext cx="12852888" cy="2200275"/>
+            <a:off x="2717556" y="7777162"/>
+            <a:ext cx="12852888" cy="1438275"/>
           </a:xfrm>
           <a:prstGeom prst="rect">
             <a:avLst/>
@@ -9426,20 +9363,61 @@
           <a:p>
             <a:pPr algn="ctr">
               <a:lnSpc>
-                <a:spcPts val="15000"/>
+                <a:spcPts val="11280"/>
               </a:lnSpc>
             </a:pPr>
             <a:r>
-              <a:rPr lang="en-US" sz="12500">
+              <a:rPr lang="en-US" sz="9400">
+                <a:solidFill>
+                  <a:srgbClr val="7D8AAB"/>
+                </a:solidFill>
+                <a:latin typeface="무궁화 고딕"/>
+                <a:ea typeface="무궁화 고딕"/>
+                <a:cs typeface="무궁화 고딕"/>
+                <a:sym typeface="무궁화 고딕"/>
+              </a:rPr>
+              <a:t>Hint. 물도 같이 들어가요</a:t>
+            </a:r>
+          </a:p>
+        </p:txBody>
+      </p:sp>
+      <p:sp>
+        <p:nvSpPr>
+          <p:cNvPr name="TextBox 5" id="5"/>
+          <p:cNvSpPr txBox="true"/>
+          <p:nvPr/>
+        </p:nvSpPr>
+        <p:spPr>
+          <a:xfrm rot="0">
+            <a:off x="2717556" y="3733800"/>
+            <a:ext cx="12852888" cy="2809875"/>
+          </a:xfrm>
+          <a:prstGeom prst="rect">
+            <a:avLst/>
+          </a:prstGeom>
+        </p:spPr>
+        <p:txBody>
+          <a:bodyPr anchor="t" rtlCol="false" tIns="0" lIns="0" bIns="0" rIns="0">
+            <a:spAutoFit/>
+          </a:bodyPr>
+          <a:lstStyle/>
+          <a:p>
+            <a:pPr algn="ctr">
+              <a:lnSpc>
+                <a:spcPts val="11041"/>
+              </a:lnSpc>
+            </a:pPr>
+            <a:r>
+              <a:rPr lang="en-US" sz="9200">
                 <a:solidFill>
                   <a:srgbClr val="000000"/>
                 </a:solidFill>
-                <a:latin typeface="Jua"/>
-                <a:ea typeface="Jua"/>
-                <a:cs typeface="Jua"/>
-                <a:sym typeface="Jua"/>
+                <a:latin typeface="무궁화 고딕"/>
+                <a:ea typeface="무궁화 고딕"/>
+                <a:cs typeface="무궁화 고딕"/>
+                <a:sym typeface="무궁화 고딕"/>
               </a:rPr>
-              <a:t>세탁기</a:t>
+              <a:t>하얀 이불을 까만 입에 넣으면 빙글빙글 돌려서 뱉어요</a:t>
             </a:r>
           </a:p>
         </p:txBody>
@@ -9492,25 +9470,50 @@
           </a:stretch>
         </p:blipFill>
         <p:spPr>
-          <a:xfrm flipH="false" flipV="false" rot="-7408585">
-            <a:off x="4499355" y="-533795"/>
-            <a:ext cx="9289290" cy="10369815"/>
+          <a:xfrm flipH="false" flipV="false" rot="0">
+            <a:off x="13655377" y="6809666"/>
+            <a:ext cx="6229999" cy="6954669"/>
           </a:xfrm>
           <a:prstGeom prst="rect">
             <a:avLst/>
           </a:prstGeom>
         </p:spPr>
       </p:pic>
-      <p:sp>
-        <p:nvSpPr>
-          <p:cNvPr name="TextBox 3" id="3"/>
+      <p:pic>
+        <p:nvPicPr>
+          <p:cNvPr name="Picture 3" id="3"/>
+          <p:cNvPicPr>
+            <a:picLocks noChangeAspect="true"/>
+          </p:cNvPicPr>
+          <p:nvPr/>
+        </p:nvPicPr>
+        <p:blipFill>
+          <a:blip r:embed="rId3"/>
+          <a:srcRect l="0" t="0" r="0" b="0"/>
+          <a:stretch>
+            <a:fillRect/>
+          </a:stretch>
+        </p:blipFill>
+        <p:spPr>
+          <a:xfrm flipH="false" flipV="false" rot="0">
+            <a:off x="0" y="0"/>
+            <a:ext cx="6925457" cy="4700654"/>
+          </a:xfrm>
+          <a:prstGeom prst="rect">
+            <a:avLst/>
+          </a:prstGeom>
+        </p:spPr>
+      </p:pic>
+      <p:sp>
+        <p:nvSpPr>
+          <p:cNvPr name="TextBox 4" id="4"/>
           <p:cNvSpPr txBox="true"/>
           <p:nvPr/>
         </p:nvSpPr>
         <p:spPr>
           <a:xfrm rot="0">
-            <a:off x="4421807" y="3895725"/>
-            <a:ext cx="9444385" cy="2200275"/>
+            <a:off x="2717556" y="4181475"/>
+            <a:ext cx="12852888" cy="1914525"/>
           </a:xfrm>
           <a:prstGeom prst="rect">
             <a:avLst/>
@@ -9532,66 +9535,16 @@
                 <a:solidFill>
                   <a:srgbClr val="000000"/>
                 </a:solidFill>
-                <a:latin typeface="Jua"/>
-                <a:ea typeface="Jua"/>
-                <a:cs typeface="Jua"/>
-                <a:sym typeface="Jua"/>
+                <a:latin typeface="무궁화 고딕"/>
+                <a:ea typeface="무궁화 고딕"/>
+                <a:cs typeface="무궁화 고딕"/>
+                <a:sym typeface="무궁화 고딕"/>
               </a:rPr>
-              <a:t>감사합니다!</a:t>
-            </a:r>
-          </a:p>
-        </p:txBody>
-      </p:sp>
-      <p:pic>
-        <p:nvPicPr>
-          <p:cNvPr name="Picture 4" id="4"/>
-          <p:cNvPicPr>
-            <a:picLocks noChangeAspect="true"/>
-          </p:cNvPicPr>
-          <p:nvPr/>
-        </p:nvPicPr>
-        <p:blipFill>
-          <a:blip r:embed="rId3"/>
-          <a:srcRect l="62989" t="67035" r="0" b="0"/>
-          <a:stretch>
-            <a:fillRect/>
-          </a:stretch>
-        </p:blipFill>
-        <p:spPr>
-          <a:xfrm flipH="false" flipV="false" rot="5400000">
-            <a:off x="-202103" y="6179918"/>
-            <a:ext cx="4312936" cy="3841377"/>
-          </a:xfrm>
-          <a:prstGeom prst="rect">
-            <a:avLst/>
-          </a:prstGeom>
-        </p:spPr>
-      </p:pic>
-      <p:pic>
-        <p:nvPicPr>
-          <p:cNvPr name="Picture 5" id="5"/>
-          <p:cNvPicPr>
-            <a:picLocks noChangeAspect="true"/>
-          </p:cNvPicPr>
-          <p:nvPr/>
-        </p:nvPicPr>
-        <p:blipFill>
-          <a:blip r:embed="rId4"/>
-          <a:srcRect l="0" t="0" r="0" b="0"/>
-          <a:stretch>
-            <a:fillRect/>
-          </a:stretch>
-        </p:blipFill>
-        <p:spPr>
-          <a:xfrm flipH="false" flipV="false" rot="0">
-            <a:off x="11640279" y="-4239083"/>
-            <a:ext cx="8152651" cy="8478165"/>
-          </a:xfrm>
-          <a:prstGeom prst="rect">
-            <a:avLst/>
-          </a:prstGeom>
-        </p:spPr>
-      </p:pic>
+              <a:t>세탁기</a:t>
+            </a:r>
+          </a:p>
+        </p:txBody>
+      </p:sp>
     </p:spTree>
   </p:cSld>
   <p:clrMapOvr>
@@ -9682,8 +9635,8 @@
         </p:nvSpPr>
         <p:spPr>
           <a:xfrm rot="0">
-            <a:off x="2717556" y="2943225"/>
-            <a:ext cx="12852888" cy="4105275"/>
+            <a:off x="2717556" y="3228975"/>
+            <a:ext cx="12852888" cy="3819525"/>
           </a:xfrm>
           <a:prstGeom prst="rect">
             <a:avLst/>
@@ -9705,10 +9658,10 @@
                 <a:solidFill>
                   <a:srgbClr val="000000"/>
                 </a:solidFill>
-                <a:latin typeface="Jua"/>
-                <a:ea typeface="Jua"/>
-                <a:cs typeface="Jua"/>
-                <a:sym typeface="Jua"/>
+                <a:latin typeface="무궁화 고딕"/>
+                <a:ea typeface="무궁화 고딕"/>
+                <a:cs typeface="무궁화 고딕"/>
+                <a:sym typeface="무궁화 고딕"/>
               </a:rPr>
               <a:t>엄마가 일어나면</a:t>
             </a:r>
@@ -9724,26 +9677,83 @@
                 <a:solidFill>
                   <a:srgbClr val="000000"/>
                 </a:solidFill>
-                <a:latin typeface="Jua"/>
-                <a:ea typeface="Jua"/>
-                <a:cs typeface="Jua"/>
-                <a:sym typeface="Jua"/>
+                <a:latin typeface="무궁화 고딕"/>
+                <a:ea typeface="무궁화 고딕"/>
+                <a:cs typeface="무궁화 고딕"/>
+                <a:sym typeface="무궁화 고딕"/>
               </a:rPr>
               <a:t>아빠가 책을 봐요</a:t>
             </a:r>
           </a:p>
         </p:txBody>
       </p:sp>
-      <p:sp>
-        <p:nvSpPr>
-          <p:cNvPr name="TextBox 5" id="5"/>
+    </p:spTree>
+  </p:cSld>
+  <p:clrMapOvr>
+    <a:masterClrMapping/>
+  </p:clrMapOvr>
+</p:sld>
+</file>
+
+<file path=ppt/slides/slide50.xml><?xml version="1.0" encoding="utf-8"?>
+<p:sld xmlns:p="http://schemas.openxmlformats.org/presentationml/2006/main" xmlns:a="http://schemas.openxmlformats.org/drawingml/2006/main" xmlns:r="http://schemas.openxmlformats.org/officeDocument/2006/relationships">
+  <p:cSld>
+    <p:bg>
+      <p:bgPr>
+        <a:solidFill>
+          <a:srgbClr val="FFFAEF"/>
+        </a:solidFill>
+      </p:bgPr>
+    </p:bg>
+    <p:spTree>
+      <p:nvGrpSpPr>
+        <p:cNvPr id="1" name=""/>
+        <p:cNvGrpSpPr/>
+        <p:nvPr/>
+      </p:nvGrpSpPr>
+      <p:grpSpPr>
+        <a:xfrm>
+          <a:off x="0" y="0"/>
+          <a:ext cx="0" cy="0"/>
+          <a:chOff x="0" y="0"/>
+          <a:chExt cx="0" cy="0"/>
+        </a:xfrm>
+      </p:grpSpPr>
+      <p:pic>
+        <p:nvPicPr>
+          <p:cNvPr name="Picture 2" id="2"/>
+          <p:cNvPicPr>
+            <a:picLocks noChangeAspect="true"/>
+          </p:cNvPicPr>
+          <p:nvPr/>
+        </p:nvPicPr>
+        <p:blipFill>
+          <a:blip r:embed="rId2"/>
+          <a:srcRect l="0" t="0" r="0" b="0"/>
+          <a:stretch>
+            <a:fillRect/>
+          </a:stretch>
+        </p:blipFill>
+        <p:spPr>
+          <a:xfrm flipH="false" flipV="false" rot="-7408585">
+            <a:off x="4499355" y="-533795"/>
+            <a:ext cx="9289290" cy="10369815"/>
+          </a:xfrm>
+          <a:prstGeom prst="rect">
+            <a:avLst/>
+          </a:prstGeom>
+        </p:spPr>
+      </p:pic>
+      <p:sp>
+        <p:nvSpPr>
+          <p:cNvPr name="TextBox 3" id="3"/>
           <p:cNvSpPr txBox="true"/>
           <p:nvPr/>
         </p:nvSpPr>
         <p:spPr>
           <a:xfrm rot="0">
-            <a:off x="2717556" y="7505700"/>
-            <a:ext cx="12852888" cy="1752600"/>
+            <a:off x="4421807" y="4181475"/>
+            <a:ext cx="9444385" cy="1914525"/>
           </a:xfrm>
           <a:prstGeom prst="rect">
             <a:avLst/>
@@ -9757,24 +9767,74 @@
           <a:p>
             <a:pPr algn="ctr">
               <a:lnSpc>
-                <a:spcPts val="11999"/>
+                <a:spcPts val="15000"/>
               </a:lnSpc>
             </a:pPr>
             <a:r>
-              <a:rPr lang="en-US" sz="9999">
+              <a:rPr lang="en-US" sz="12500">
                 <a:solidFill>
-                  <a:srgbClr val="7D8AAB"/>
+                  <a:srgbClr val="000000"/>
                 </a:solidFill>
-                <a:latin typeface="Jua"/>
-                <a:ea typeface="Jua"/>
-                <a:cs typeface="Jua"/>
-                <a:sym typeface="Jua"/>
+                <a:latin typeface="무궁화 고딕"/>
+                <a:ea typeface="무궁화 고딕"/>
+                <a:cs typeface="무궁화 고딕"/>
+                <a:sym typeface="무궁화 고딕"/>
               </a:rPr>
-              <a:t>Hint. 번호를 눌러요</a:t>
-            </a:r>
-          </a:p>
-        </p:txBody>
-      </p:sp>
+              <a:t>감사합니다!</a:t>
+            </a:r>
+          </a:p>
+        </p:txBody>
+      </p:sp>
+      <p:pic>
+        <p:nvPicPr>
+          <p:cNvPr name="Picture 4" id="4"/>
+          <p:cNvPicPr>
+            <a:picLocks noChangeAspect="true"/>
+          </p:cNvPicPr>
+          <p:nvPr/>
+        </p:nvPicPr>
+        <p:blipFill>
+          <a:blip r:embed="rId3"/>
+          <a:srcRect l="62989" t="67035" r="0" b="0"/>
+          <a:stretch>
+            <a:fillRect/>
+          </a:stretch>
+        </p:blipFill>
+        <p:spPr>
+          <a:xfrm flipH="false" flipV="false" rot="5400000">
+            <a:off x="-202103" y="6179918"/>
+            <a:ext cx="4312936" cy="3841377"/>
+          </a:xfrm>
+          <a:prstGeom prst="rect">
+            <a:avLst/>
+          </a:prstGeom>
+        </p:spPr>
+      </p:pic>
+      <p:pic>
+        <p:nvPicPr>
+          <p:cNvPr name="Picture 5" id="5"/>
+          <p:cNvPicPr>
+            <a:picLocks noChangeAspect="true"/>
+          </p:cNvPicPr>
+          <p:nvPr/>
+        </p:nvPicPr>
+        <p:blipFill>
+          <a:blip r:embed="rId4"/>
+          <a:srcRect l="0" t="0" r="0" b="0"/>
+          <a:stretch>
+            <a:fillRect/>
+          </a:stretch>
+        </p:blipFill>
+        <p:spPr>
+          <a:xfrm flipH="false" flipV="false" rot="0">
+            <a:off x="11640279" y="-4239083"/>
+            <a:ext cx="8152651" cy="8478165"/>
+          </a:xfrm>
+          <a:prstGeom prst="rect">
+            <a:avLst/>
+          </a:prstGeom>
+        </p:spPr>
+      </p:pic>
     </p:spTree>
   </p:cSld>
   <p:clrMapOvr>
@@ -9865,8 +9925,8 @@
         </p:nvSpPr>
         <p:spPr>
           <a:xfrm rot="0">
-            <a:off x="2717556" y="3895725"/>
-            <a:ext cx="12852888" cy="2200275"/>
+            <a:off x="2717556" y="3228975"/>
+            <a:ext cx="12852888" cy="3819525"/>
           </a:xfrm>
           <a:prstGeom prst="rect">
             <a:avLst/>
@@ -9888,12 +9948,72 @@
                 <a:solidFill>
                   <a:srgbClr val="000000"/>
                 </a:solidFill>
-                <a:latin typeface="Jua"/>
-                <a:ea typeface="Jua"/>
-                <a:cs typeface="Jua"/>
-                <a:sym typeface="Jua"/>
+                <a:latin typeface="무궁화 고딕"/>
+                <a:ea typeface="무궁화 고딕"/>
+                <a:cs typeface="무궁화 고딕"/>
+                <a:sym typeface="무궁화 고딕"/>
               </a:rPr>
-              <a:t>노래방</a:t>
+              <a:t>엄마가 일어나면</a:t>
+            </a:r>
+          </a:p>
+          <a:p>
+            <a:pPr algn="ctr">
+              <a:lnSpc>
+                <a:spcPts val="15000"/>
+              </a:lnSpc>
+            </a:pPr>
+            <a:r>
+              <a:rPr lang="en-US" sz="12500">
+                <a:solidFill>
+                  <a:srgbClr val="000000"/>
+                </a:solidFill>
+                <a:latin typeface="무궁화 고딕"/>
+                <a:ea typeface="무궁화 고딕"/>
+                <a:cs typeface="무궁화 고딕"/>
+                <a:sym typeface="무궁화 고딕"/>
+              </a:rPr>
+              <a:t>아빠가 책을 봐요</a:t>
+            </a:r>
+          </a:p>
+        </p:txBody>
+      </p:sp>
+      <p:sp>
+        <p:nvSpPr>
+          <p:cNvPr name="TextBox 5" id="5"/>
+          <p:cNvSpPr txBox="true"/>
+          <p:nvPr/>
+        </p:nvSpPr>
+        <p:spPr>
+          <a:xfrm rot="0">
+            <a:off x="2717556" y="7743825"/>
+            <a:ext cx="12852888" cy="1514475"/>
+          </a:xfrm>
+          <a:prstGeom prst="rect">
+            <a:avLst/>
+          </a:prstGeom>
+        </p:spPr>
+        <p:txBody>
+          <a:bodyPr anchor="t" rtlCol="false" tIns="0" lIns="0" bIns="0" rIns="0">
+            <a:spAutoFit/>
+          </a:bodyPr>
+          <a:lstStyle/>
+          <a:p>
+            <a:pPr algn="ctr">
+              <a:lnSpc>
+                <a:spcPts val="11999"/>
+              </a:lnSpc>
+            </a:pPr>
+            <a:r>
+              <a:rPr lang="en-US" sz="9999">
+                <a:solidFill>
+                  <a:srgbClr val="7D8AAB"/>
+                </a:solidFill>
+                <a:latin typeface="무궁화 고딕"/>
+                <a:ea typeface="무궁화 고딕"/>
+                <a:cs typeface="무궁화 고딕"/>
+                <a:sym typeface="무궁화 고딕"/>
+              </a:rPr>
+              <a:t>Hint. 번호를 눌러요</a:t>
             </a:r>
           </a:p>
         </p:txBody>
@@ -9988,8 +10108,8 @@
         </p:nvSpPr>
         <p:spPr>
           <a:xfrm rot="0">
-            <a:off x="2717556" y="2943225"/>
-            <a:ext cx="13294045" cy="4105275"/>
+            <a:off x="2717556" y="4181475"/>
+            <a:ext cx="12852888" cy="1914525"/>
           </a:xfrm>
           <a:prstGeom prst="rect">
             <a:avLst/>
@@ -10011,31 +10131,12 @@
                 <a:solidFill>
                   <a:srgbClr val="000000"/>
                 </a:solidFill>
-                <a:latin typeface="Jua"/>
-                <a:ea typeface="Jua"/>
-                <a:cs typeface="Jua"/>
-                <a:sym typeface="Jua"/>
+                <a:latin typeface="무궁화 고딕"/>
+                <a:ea typeface="무궁화 고딕"/>
+                <a:cs typeface="무궁화 고딕"/>
+                <a:sym typeface="무궁화 고딕"/>
               </a:rPr>
-              <a:t>아빠가 거울 보면서</a:t>
-            </a:r>
-          </a:p>
-          <a:p>
-            <a:pPr algn="ctr">
-              <a:lnSpc>
-                <a:spcPts val="15000"/>
-              </a:lnSpc>
-            </a:pPr>
-            <a:r>
-              <a:rPr lang="en-US" sz="12500">
-                <a:solidFill>
-                  <a:srgbClr val="000000"/>
-                </a:solidFill>
-                <a:latin typeface="Jua"/>
-                <a:ea typeface="Jua"/>
-                <a:cs typeface="Jua"/>
-                <a:sym typeface="Jua"/>
-              </a:rPr>
-              <a:t>얼굴에 거품 파티 해요</a:t>
+              <a:t>노래방</a:t>
             </a:r>
           </a:p>
         </p:txBody>
@@ -10130,8 +10231,8 @@
         </p:nvSpPr>
         <p:spPr>
           <a:xfrm rot="0">
-            <a:off x="2717556" y="7505700"/>
-            <a:ext cx="12852888" cy="1752600"/>
+            <a:off x="2717556" y="3343275"/>
+            <a:ext cx="13294045" cy="3590925"/>
           </a:xfrm>
           <a:prstGeom prst="rect">
             <a:avLst/>
@@ -10145,59 +10246,18 @@
           <a:p>
             <a:pPr algn="ctr">
               <a:lnSpc>
-                <a:spcPts val="11999"/>
+                <a:spcPts val="14160"/>
               </a:lnSpc>
             </a:pPr>
             <a:r>
-              <a:rPr lang="en-US" sz="9999">
-                <a:solidFill>
-                  <a:srgbClr val="7D8AAB"/>
-                </a:solidFill>
-                <a:latin typeface="Jua"/>
-                <a:ea typeface="Jua"/>
-                <a:cs typeface="Jua"/>
-                <a:sym typeface="Jua"/>
-              </a:rPr>
-              <a:t>Hint. 아빠만 해요</a:t>
-            </a:r>
-          </a:p>
-        </p:txBody>
-      </p:sp>
-      <p:sp>
-        <p:nvSpPr>
-          <p:cNvPr name="TextBox 5" id="5"/>
-          <p:cNvSpPr txBox="true"/>
-          <p:nvPr/>
-        </p:nvSpPr>
-        <p:spPr>
-          <a:xfrm rot="0">
-            <a:off x="2717556" y="2943225"/>
-            <a:ext cx="13294045" cy="4105275"/>
-          </a:xfrm>
-          <a:prstGeom prst="rect">
-            <a:avLst/>
-          </a:prstGeom>
-        </p:spPr>
-        <p:txBody>
-          <a:bodyPr anchor="t" rtlCol="false" tIns="0" lIns="0" bIns="0" rIns="0">
-            <a:spAutoFit/>
-          </a:bodyPr>
-          <a:lstStyle/>
-          <a:p>
-            <a:pPr algn="ctr">
-              <a:lnSpc>
-                <a:spcPts val="15000"/>
-              </a:lnSpc>
-            </a:pPr>
-            <a:r>
-              <a:rPr lang="en-US" sz="12500">
+              <a:rPr lang="en-US" sz="11800">
                 <a:solidFill>
                   <a:srgbClr val="000000"/>
                 </a:solidFill>
-                <a:latin typeface="Jua"/>
-                <a:ea typeface="Jua"/>
-                <a:cs typeface="Jua"/>
-                <a:sym typeface="Jua"/>
+                <a:latin typeface="무궁화 고딕"/>
+                <a:ea typeface="무궁화 고딕"/>
+                <a:cs typeface="무궁화 고딕"/>
+                <a:sym typeface="무궁화 고딕"/>
               </a:rPr>
               <a:t>아빠가 거울 보면서</a:t>
             </a:r>
@@ -10205,18 +10265,18 @@
           <a:p>
             <a:pPr algn="ctr">
               <a:lnSpc>
-                <a:spcPts val="15000"/>
+                <a:spcPts val="14160"/>
               </a:lnSpc>
             </a:pPr>
             <a:r>
-              <a:rPr lang="en-US" sz="12500">
+              <a:rPr lang="en-US" sz="11800">
                 <a:solidFill>
                   <a:srgbClr val="000000"/>
                 </a:solidFill>
-                <a:latin typeface="Jua"/>
-                <a:ea typeface="Jua"/>
-                <a:cs typeface="Jua"/>
-                <a:sym typeface="Jua"/>
+                <a:latin typeface="무궁화 고딕"/>
+                <a:ea typeface="무궁화 고딕"/>
+                <a:cs typeface="무궁화 고딕"/>
+                <a:sym typeface="무궁화 고딕"/>
               </a:rPr>
               <a:t>얼굴에 거품 파티 해요</a:t>
             </a:r>
@@ -10313,8 +10373,8 @@
         </p:nvSpPr>
         <p:spPr>
           <a:xfrm rot="0">
-            <a:off x="2717556" y="3895725"/>
-            <a:ext cx="12852888" cy="2200275"/>
+            <a:off x="2717556" y="7743825"/>
+            <a:ext cx="12852888" cy="1514475"/>
           </a:xfrm>
           <a:prstGeom prst="rect">
             <a:avLst/>
@@ -10328,20 +10388,80 @@
           <a:p>
             <a:pPr algn="ctr">
               <a:lnSpc>
-                <a:spcPts val="15000"/>
+                <a:spcPts val="11999"/>
               </a:lnSpc>
             </a:pPr>
             <a:r>
-              <a:rPr lang="en-US" sz="12500">
+              <a:rPr lang="en-US" sz="9999">
+                <a:solidFill>
+                  <a:srgbClr val="7D8AAB"/>
+                </a:solidFill>
+                <a:latin typeface="무궁화 고딕"/>
+                <a:ea typeface="무궁화 고딕"/>
+                <a:cs typeface="무궁화 고딕"/>
+                <a:sym typeface="무궁화 고딕"/>
+              </a:rPr>
+              <a:t>Hint. 아빠만 해요</a:t>
+            </a:r>
+          </a:p>
+        </p:txBody>
+      </p:sp>
+      <p:sp>
+        <p:nvSpPr>
+          <p:cNvPr name="TextBox 5" id="5"/>
+          <p:cNvSpPr txBox="true"/>
+          <p:nvPr/>
+        </p:nvSpPr>
+        <p:spPr>
+          <a:xfrm rot="0">
+            <a:off x="2717556" y="3343275"/>
+            <a:ext cx="13294045" cy="3590925"/>
+          </a:xfrm>
+          <a:prstGeom prst="rect">
+            <a:avLst/>
+          </a:prstGeom>
+        </p:spPr>
+        <p:txBody>
+          <a:bodyPr anchor="t" rtlCol="false" tIns="0" lIns="0" bIns="0" rIns="0">
+            <a:spAutoFit/>
+          </a:bodyPr>
+          <a:lstStyle/>
+          <a:p>
+            <a:pPr algn="ctr">
+              <a:lnSpc>
+                <a:spcPts val="14160"/>
+              </a:lnSpc>
+            </a:pPr>
+            <a:r>
+              <a:rPr lang="en-US" sz="11800">
                 <a:solidFill>
                   <a:srgbClr val="000000"/>
                 </a:solidFill>
-                <a:latin typeface="Jua"/>
-                <a:ea typeface="Jua"/>
-                <a:cs typeface="Jua"/>
-                <a:sym typeface="Jua"/>
+                <a:latin typeface="무궁화 고딕"/>
+                <a:ea typeface="무궁화 고딕"/>
+                <a:cs typeface="무궁화 고딕"/>
+                <a:sym typeface="무궁화 고딕"/>
               </a:rPr>
-              <a:t>면도</a:t>
+              <a:t>아빠가 거울 보면서</a:t>
+            </a:r>
+          </a:p>
+          <a:p>
+            <a:pPr algn="ctr">
+              <a:lnSpc>
+                <a:spcPts val="14160"/>
+              </a:lnSpc>
+            </a:pPr>
+            <a:r>
+              <a:rPr lang="en-US" sz="11800">
+                <a:solidFill>
+                  <a:srgbClr val="000000"/>
+                </a:solidFill>
+                <a:latin typeface="무궁화 고딕"/>
+                <a:ea typeface="무궁화 고딕"/>
+                <a:cs typeface="무궁화 고딕"/>
+                <a:sym typeface="무궁화 고딕"/>
+              </a:rPr>
+              <a:t>얼굴에 거품 파티 해요</a:t>
             </a:r>
           </a:p>
         </p:txBody>

</xml_diff>